<commit_message>
Pitch-Paket: Kids-Day-Modul, Rufbereitschaft, Preis 4.400 EUR
- Neue Slide 14: Kids-Day als separates Planungsmodul — thema-agnostisch
  (Märchenwald war letztes Jahr), Schwerpunkt kinderfreundliche Kostüme,
  gleiche Plattform-Mechanik wie Eventnacht
- Eventnacht-Support ehrlich umgeschrieben: Remote-Rufbereitschaft,
  Nachtschicht inklusive — kein "vor Ort am Leitstand" (du bist Actor
  und an Halloween mit deinen Kindern unterwegs)
- Kostenaufstellung: neue Pos. 2 Kids-Day-Planungsmodul (400 EUR),
  Eventnacht-Support → Rufbereitschaft (400 EUR), 7 Positionen,
  Summe 4.400 EUR Freundschaftspreis (marktüblich 12.800 EUR)
- Backfisch-Garantie und alle Pos.-Referenzen auf neue Nummerierung
  angepasst (Pos. 5/6 statt 4/5)

https://claude.ai/code/session_01621xjFv5F5obApa2cLfE8E
</commit_message>
<xml_diff>
--- a/pitch/Horrorgeticon_Ops_Pitchdeck.pptx
+++ b/pitch/Horrorgeticon_Ops_Pitchdeck.pptx
@@ -23,6 +23,7 @@
     <p:sldId id="271" r:id="rId22"/>
     <p:sldId id="272" r:id="rId23"/>
     <p:sldId id="273" r:id="rId24"/>
+    <p:sldId id="274" r:id="rId25"/>
   </p:sldIdLst>
   <p:sldSz cx="12191695" cy="6858000" type="screen4x3"/>
   <p:notesSz cx="6858000" cy="9144000"/>
@@ -5381,7 +5382,7 @@
     <p:bg>
       <p:bgPr>
         <a:solidFill>
-          <a:srgbClr val="071628"/>
+          <a:srgbClr val="F8F6F2"/>
         </a:solidFill>
         <a:effectLst/>
       </p:bgPr>
@@ -5422,7 +5423,7 @@
                 </a:solidFill>
                 <a:latin typeface="DM Sans"/>
               </a:rPr>
-              <a:t>TECHNIK</a:t>
+              <a:t>BONUS · TAGESPROGRAMM</a:t>
             </a:r>
           </a:p>
         </p:txBody>
@@ -5450,13 +5451,13 @@
           <a:lstStyle/>
           <a:p>
             <a:r>
-              <a:rPr sz="3000" b="1">
-                <a:solidFill>
-                  <a:srgbClr val="F8F6F2"/>
+              <a:rPr sz="2600" b="1">
+                <a:solidFill>
+                  <a:srgbClr val="0D2847"/>
                 </a:solidFill>
                 <a:latin typeface="Nunito"/>
               </a:rPr>
-              <a:t>Gebaut für Acker, LAN und müde Menschen. 🖥️</a:t>
+              <a:t>Kids-Day: ein eigenes Planungsmodul im Leitstand. 🎠</a:t>
             </a:r>
           </a:p>
         </p:txBody>
@@ -5486,11 +5487,11 @@
             <a:r>
               <a:rPr sz="1400">
                 <a:solidFill>
-                  <a:srgbClr val="CFD9E6"/>
-                </a:solidFill>
-                <a:latin typeface="DM Sans"/>
-              </a:rPr>
-              <a:t>Dünne Geräte, zentrale Wahrheit, robuste Betriebslogik. Läuft auf einem Laptop im Crew-Büro — kein Cloud-Zwang, keine Abhängigkeit von Festival-WLAN-Wundern.</a:t>
+                  <a:srgbClr val="4F4F4F"/>
+                </a:solidFill>
+                <a:latin typeface="DM Sans"/>
+              </a:rPr>
+              <a:t>Tagsüber Familienprogramm statt Horror — letztes Jahr war es der Märchenwald, was 2026 wird, steht noch nicht fest. Das Modul ist thema-agnostisch: Setting, Zonen und Checklisten werden pro Jahr konfiguriert, nicht neu programmiert.</a:t>
             </a:r>
           </a:p>
         </p:txBody>
@@ -5504,7 +5505,7 @@
         <p:spPr>
           <a:xfrm>
             <a:off x="685800" y="2377440"/>
-            <a:ext cx="3502152" cy="2377440"/>
+            <a:ext cx="3502152" cy="2286000"/>
           </a:xfrm>
           <a:prstGeom prst="roundRect">
             <a:avLst>
@@ -5512,11 +5513,11 @@
             </a:avLst>
           </a:prstGeom>
           <a:solidFill>
-            <a:srgbClr val="143255"/>
+            <a:srgbClr val="FFFFFF"/>
           </a:solidFill>
           <a:ln w="9525">
             <a:solidFill>
-              <a:srgbClr val="2A4A70"/>
+              <a:srgbClr val="E6E1D8"/>
             </a:solidFill>
           </a:ln>
           <a:effectLst/>
@@ -5543,11 +5544,11 @@
             <a:r>
               <a:rPr sz="1250" b="1">
                 <a:solidFill>
-                  <a:srgbClr val="F8F6F2"/>
+                  <a:srgbClr val="0D2847"/>
                 </a:solidFill>
                 <a:latin typeface="Nunito"/>
               </a:rPr>
-              <a:t>🧩 Null Abhängigkeiten</a:t>
+              <a:t>👗 Kostüme im Mittelpunkt</a:t>
             </a:r>
           </a:p>
           <a:p>
@@ -5559,11 +5560,11 @@
             <a:r>
               <a:rPr sz="1050">
                 <a:solidFill>
-                  <a:srgbClr val="B9C6D6"/>
-                </a:solidFill>
-                <a:latin typeface="DM Sans"/>
-              </a:rPr>
-              <a:t>Ein Node.js-Server, keine fremden Pakete. PWA im Browser, native Shells für Windows/Android/iOS optional. Weniger Magie, mehr Kontrolle im Feld.</a:t>
+                  <a:srgbClr val="4F4F4F"/>
+                </a:solidFill>
+                <a:latin typeface="DM Sans"/>
+              </a:rPr>
+              <a:t>Kinderfreundlich-Freigabe pro Kostüm, Zuordnung zu Personen und Positionen, Check vor Einlass: kein Kunstblut, keine Schreckmasken.</a:t>
             </a:r>
           </a:p>
         </p:txBody>
@@ -5577,7 +5578,7 @@
         <p:spPr>
           <a:xfrm>
             <a:off x="4416552" y="2377440"/>
-            <a:ext cx="3502152" cy="2377440"/>
+            <a:ext cx="3502152" cy="2286000"/>
           </a:xfrm>
           <a:prstGeom prst="roundRect">
             <a:avLst>
@@ -5585,11 +5586,11 @@
             </a:avLst>
           </a:prstGeom>
           <a:solidFill>
-            <a:srgbClr val="143255"/>
+            <a:srgbClr val="FFFFFF"/>
           </a:solidFill>
           <a:ln w="9525">
             <a:solidFill>
-              <a:srgbClr val="2A4A70"/>
+              <a:srgbClr val="E6E1D8"/>
             </a:solidFill>
           </a:ln>
           <a:effectLst/>
@@ -5616,11 +5617,11 @@
             <a:r>
               <a:rPr sz="1250" b="1">
                 <a:solidFill>
-                  <a:srgbClr val="F8F6F2"/>
+                  <a:srgbClr val="0D2847"/>
                 </a:solidFill>
                 <a:latin typeface="Nunito"/>
               </a:rPr>
-              <a:t>⚡ Live ohne Refresh-Ritual</a:t>
+              <a:t>🎠 Thema pro Saison</a:t>
             </a:r>
           </a:p>
           <a:p>
@@ -5632,11 +5633,11 @@
             <a:r>
               <a:rPr sz="1050">
                 <a:solidFill>
-                  <a:srgbClr val="B9C6D6"/>
-                </a:solidFill>
-                <a:latin typeface="DM Sans"/>
-              </a:rPr>
-              <a:t>Server-Sent Events pushen jede Änderung an alle Sichten. Heartbeats erkennen Funklöcher, bevor sie ein Problem sind.</a:t>
+                  <a:srgbClr val="4F4F4F"/>
+                </a:solidFill>
+                <a:latin typeface="DM Sans"/>
+              </a:rPr>
+              <a:t>Märchenwald, Piratenbucht oder was 2026 eben wird — das Setting wechselt, die Plattform bleibt dieselbe.</a:t>
             </a:r>
           </a:p>
         </p:txBody>
@@ -5650,7 +5651,7 @@
         <p:spPr>
           <a:xfrm>
             <a:off x="8147304" y="2377440"/>
-            <a:ext cx="3502152" cy="2377440"/>
+            <a:ext cx="3502152" cy="2286000"/>
           </a:xfrm>
           <a:prstGeom prst="roundRect">
             <a:avLst>
@@ -5658,11 +5659,11 @@
             </a:avLst>
           </a:prstGeom>
           <a:solidFill>
-            <a:srgbClr val="143255"/>
+            <a:srgbClr val="FFFFFF"/>
           </a:solidFill>
           <a:ln w="9525">
             <a:solidFill>
-              <a:srgbClr val="2A4A70"/>
+              <a:srgbClr val="E6E1D8"/>
             </a:solidFill>
           </a:ln>
           <a:effectLst/>
@@ -5689,11 +5690,11 @@
             <a:r>
               <a:rPr sz="1250" b="1">
                 <a:solidFill>
-                  <a:srgbClr val="F8F6F2"/>
+                  <a:srgbClr val="0D2847"/>
                 </a:solidFill>
                 <a:latin typeface="Nunito"/>
               </a:rPr>
-              <a:t>🛡️ Unkaputtbar gedacht</a:t>
+              <a:t>♻️ Gleiche Plattform, gleiche Crew</a:t>
             </a:r>
           </a:p>
           <a:p>
@@ -5705,37 +5706,69 @@
             <a:r>
               <a:rPr sz="1050">
                 <a:solidFill>
-                  <a:srgbClr val="B9C6D6"/>
-                </a:solidFill>
-                <a:latin typeface="DM Sans"/>
-              </a:rPr>
-              <a:t>Append-only-Journal, atomare Snapshots, rotierende Backups, Selbstreparatur beim Start. Stolpert ein Modul, läuft der Rest weiter (Circuit-Breaker).</a:t>
-            </a:r>
-          </a:p>
-        </p:txBody>
-      </p:sp>
-      <p:sp>
-        <p:nvSpPr>
-          <p:cNvPr id="8" name="Rounded Rectangle 7"/>
+                  <a:srgbClr val="4F4F4F"/>
+                </a:solidFill>
+                <a:latin typeface="DM Sans"/>
+              </a:rPr>
+              <a:t>Tagesschichten, Aufgaben, Catering-Marken und Karte laufen identisch — nur das Setting wechselt von Grusel auf Glitzer.</a:t>
+            </a:r>
+          </a:p>
+        </p:txBody>
+      </p:sp>
+      <p:sp>
+        <p:nvSpPr>
+          <p:cNvPr id="8" name="TextBox 7"/>
+          <p:cNvSpPr txBox="1"/>
+          <p:nvPr/>
+        </p:nvSpPr>
+        <p:spPr>
+          <a:xfrm>
+            <a:off x="713232" y="5074920"/>
+            <a:ext cx="10058400" cy="365760"/>
+          </a:xfrm>
+          <a:prstGeom prst="rect">
+            <a:avLst/>
+          </a:prstGeom>
+          <a:noFill/>
+        </p:spPr>
+        <p:txBody>
+          <a:bodyPr wrap="square">
+            <a:spAutoFit/>
+          </a:bodyPr>
+          <a:lstStyle/>
+          <a:p>
+            <a:r>
+              <a:rPr sz="1100">
+                <a:solidFill>
+                  <a:srgbClr val="828282"/>
+                </a:solidFill>
+                <a:latin typeface="DM Sans"/>
+              </a:rPr>
+              <a:t>Kunstblut hat an diesem Tag Hausverbot.</a:t>
+            </a:r>
+          </a:p>
+        </p:txBody>
+      </p:sp>
+      <p:sp>
+        <p:nvSpPr>
+          <p:cNvPr id="9" name="Rectangle 8"/>
           <p:cNvSpPr/>
           <p:nvPr/>
         </p:nvSpPr>
         <p:spPr>
-          <a:xfrm>
-            <a:off x="685800" y="5120640"/>
-            <a:ext cx="2286000" cy="329184"/>
-          </a:xfrm>
-          <a:prstGeom prst="roundRect">
-            <a:avLst>
-              <a:gd name="adj" fmla="val 50000"/>
-            </a:avLst>
+          <a:xfrm rot="120000">
+            <a:off x="8138160" y="5486400"/>
+            <a:ext cx="3200400" cy="868680"/>
+          </a:xfrm>
+          <a:prstGeom prst="rect">
+            <a:avLst/>
           </a:prstGeom>
           <a:solidFill>
-            <a:srgbClr val="143255"/>
+            <a:srgbClr val="FDF6E3"/>
           </a:solidFill>
-          <a:ln w="9525">
+          <a:ln w="12700">
             <a:solidFill>
-              <a:srgbClr val="2A4A70"/>
+              <a:srgbClr val="E2B93B"/>
             </a:solidFill>
           </a:ln>
           <a:effectLst/>
@@ -5755,139 +5788,27 @@
           </a:fontRef>
         </p:style>
         <p:txBody>
-          <a:bodyPr rtlCol="0" anchor="ctr" lIns="45720" rIns="45720" tIns="0" bIns="0"/>
+          <a:bodyPr rtlCol="0" anchor="ctr" wrap="square" lIns="109728" rIns="109728" tIns="73152">
+            <a:noAutofit/>
+          </a:bodyPr>
           <a:lstStyle/>
           <a:p>
             <a:pPr algn="ctr"/>
             <a:r>
-              <a:rPr sz="1000" b="1">
-                <a:solidFill>
-                  <a:srgbClr val="CFD9E6"/>
-                </a:solidFill>
-                <a:latin typeface="DM Sans"/>
-              </a:rPr>
-              <a:t>125 API-End-to-End-Checks</a:t>
-            </a:r>
-          </a:p>
-        </p:txBody>
-      </p:sp>
-      <p:sp>
-        <p:nvSpPr>
-          <p:cNvPr id="9" name="Rounded Rectangle 8"/>
-          <p:cNvSpPr/>
-          <p:nvPr/>
-        </p:nvSpPr>
-        <p:spPr>
-          <a:xfrm>
-            <a:off x="3063240" y="5120640"/>
-            <a:ext cx="2011680" cy="329184"/>
-          </a:xfrm>
-          <a:prstGeom prst="roundRect">
-            <a:avLst>
-              <a:gd name="adj" fmla="val 50000"/>
-            </a:avLst>
-          </a:prstGeom>
-          <a:solidFill>
-            <a:srgbClr val="143255"/>
-          </a:solidFill>
-          <a:ln w="9525">
-            <a:solidFill>
-              <a:srgbClr val="2A4A70"/>
-            </a:solidFill>
-          </a:ln>
-          <a:effectLst/>
-        </p:spPr>
-        <p:style>
-          <a:lnRef idx="1">
-            <a:schemeClr val="accent1"/>
-          </a:lnRef>
-          <a:fillRef idx="3">
-            <a:schemeClr val="accent1"/>
-          </a:fillRef>
-          <a:effectRef idx="2">
-            <a:schemeClr val="accent1"/>
-          </a:effectRef>
-          <a:fontRef idx="minor">
-            <a:schemeClr val="lt1"/>
-          </a:fontRef>
-        </p:style>
-        <p:txBody>
-          <a:bodyPr rtlCol="0" anchor="ctr" lIns="45720" rIns="45720" tIns="0" bIns="0"/>
-          <a:lstStyle/>
-          <a:p>
-            <a:pPr algn="ctr"/>
-            <a:r>
-              <a:rPr sz="1000" b="1">
-                <a:solidFill>
-                  <a:srgbClr val="CFD9E6"/>
-                </a:solidFill>
-                <a:latin typeface="DM Sans"/>
-              </a:rPr>
-              <a:t>47 Browser-E2E-Checks</a:t>
-            </a:r>
-          </a:p>
-        </p:txBody>
-      </p:sp>
-      <p:sp>
-        <p:nvSpPr>
-          <p:cNvPr id="10" name="Rounded Rectangle 9"/>
-          <p:cNvSpPr/>
-          <p:nvPr/>
-        </p:nvSpPr>
-        <p:spPr>
-          <a:xfrm>
-            <a:off x="5166360" y="5120640"/>
-            <a:ext cx="4389120" cy="329184"/>
-          </a:xfrm>
-          <a:prstGeom prst="roundRect">
-            <a:avLst>
-              <a:gd name="adj" fmla="val 50000"/>
-            </a:avLst>
-          </a:prstGeom>
-          <a:solidFill>
-            <a:srgbClr val="143255"/>
-          </a:solidFill>
-          <a:ln w="9525">
-            <a:solidFill>
-              <a:srgbClr val="2A4A70"/>
-            </a:solidFill>
-          </a:ln>
-          <a:effectLst/>
-        </p:spPr>
-        <p:style>
-          <a:lnRef idx="1">
-            <a:schemeClr val="accent1"/>
-          </a:lnRef>
-          <a:fillRef idx="3">
-            <a:schemeClr val="accent1"/>
-          </a:fillRef>
-          <a:effectRef idx="2">
-            <a:schemeClr val="accent1"/>
-          </a:effectRef>
-          <a:fontRef idx="minor">
-            <a:schemeClr val="lt1"/>
-          </a:fontRef>
-        </p:style>
-        <p:txBody>
-          <a:bodyPr rtlCol="0" anchor="ctr" lIns="45720" rIns="45720" tIns="0" bIns="0"/>
-          <a:lstStyle/>
-          <a:p>
-            <a:pPr algn="ctr"/>
-            <a:r>
-              <a:rPr sz="1000" b="1">
-                <a:solidFill>
-                  <a:srgbClr val="CFD9E6"/>
-                </a:solidFill>
-                <a:latin typeface="DM Sans"/>
-              </a:rPr>
-              <a:t>CSV-Import mit Dry-Run — eure Excel darf einmal noch glänzen</a:t>
-            </a:r>
-          </a:p>
-        </p:txBody>
-      </p:sp>
-      <p:sp>
-        <p:nvSpPr>
-          <p:cNvPr id="11" name="TextBox 10"/>
+              <a:rPr sz="950" b="1">
+                <a:solidFill>
+                  <a:srgbClr val="6B5A1E"/>
+                </a:solidFill>
+                <a:latin typeface="Nunito"/>
+              </a:rPr>
+              <a:t>Anderes Publikum, gleiche Orga-Probleme: Wer steht wo, wer hat Pause, wer hat sein Kostüm? Der Leitstand kann das schon.</a:t>
+            </a:r>
+          </a:p>
+        </p:txBody>
+      </p:sp>
+      <p:sp>
+        <p:nvSpPr>
+          <p:cNvPr id="10" name="TextBox 9"/>
           <p:cNvSpPr txBox="1"/>
           <p:nvPr/>
         </p:nvSpPr>
@@ -5910,18 +5831,18 @@
             <a:r>
               <a:rPr sz="900">
                 <a:solidFill>
-                  <a:srgbClr val="7E93A9"/>
-                </a:solidFill>
-                <a:latin typeface="DM Sans"/>
-              </a:rPr>
-              <a:t>14 · Technik</a:t>
-            </a:r>
-          </a:p>
-        </p:txBody>
-      </p:sp>
-      <p:sp>
-        <p:nvSpPr>
-          <p:cNvPr id="12" name="TextBox 11"/>
+                  <a:srgbClr val="828282"/>
+                </a:solidFill>
+                <a:latin typeface="DM Sans"/>
+              </a:rPr>
+              <a:t>14 · Kids-Day</a:t>
+            </a:r>
+          </a:p>
+        </p:txBody>
+      </p:sp>
+      <p:sp>
+        <p:nvSpPr>
+          <p:cNvPr id="11" name="TextBox 10"/>
           <p:cNvSpPr txBox="1"/>
           <p:nvPr/>
         </p:nvSpPr>
@@ -5945,7 +5866,7 @@
             <a:r>
               <a:rPr sz="900" i="1">
                 <a:solidFill>
-                  <a:srgbClr val="7E93A9"/>
+                  <a:srgbClr val="828282"/>
                 </a:solidFill>
                 <a:latin typeface="DM Sans"/>
               </a:rPr>
@@ -5968,7 +5889,7 @@
     <p:bg>
       <p:bgPr>
         <a:solidFill>
-          <a:srgbClr val="F8F6F2"/>
+          <a:srgbClr val="071628"/>
         </a:solidFill>
         <a:effectLst/>
       </p:bgPr>
@@ -6009,7 +5930,7 @@
                 </a:solidFill>
                 <a:latin typeface="DM Sans"/>
               </a:rPr>
-              <a:t>ERWARTUNGSMANAGEMENT</a:t>
+              <a:t>TECHNIK</a:t>
             </a:r>
           </a:p>
         </p:txBody>
@@ -6039,11 +5960,11 @@
             <a:r>
               <a:rPr sz="3000" b="1">
                 <a:solidFill>
-                  <a:srgbClr val="0D2847"/>
+                  <a:srgbClr val="F8F6F2"/>
                 </a:solidFill>
                 <a:latin typeface="Nunito"/>
               </a:rPr>
-              <a:t>Ehrlich gesagt — was es nicht ist. 🤝</a:t>
+              <a:t>Gebaut für Acker, LAN und müde Menschen. 🖥️</a:t>
             </a:r>
           </a:p>
         </p:txBody>
@@ -6073,231 +5994,37 @@
             <a:r>
               <a:rPr sz="1400">
                 <a:solidFill>
-                  <a:srgbClr val="4F4F4F"/>
-                </a:solidFill>
-                <a:latin typeface="DM Sans"/>
-              </a:rPr>
-              <a:t>Damit wir über dasselbe reden. Lieber jetzt als am 31.10. um 22:15 Uhr.</a:t>
-            </a:r>
-          </a:p>
-        </p:txBody>
-      </p:sp>
-      <p:sp>
-        <p:nvSpPr>
-          <p:cNvPr id="5" name="TextBox 4"/>
-          <p:cNvSpPr txBox="1"/>
-          <p:nvPr/>
-        </p:nvSpPr>
-        <p:spPr>
-          <a:xfrm>
-            <a:off x="685800" y="2240280"/>
-            <a:ext cx="5212080" cy="3291840"/>
-          </a:xfrm>
-          <a:prstGeom prst="rect">
-            <a:avLst/>
-          </a:prstGeom>
-          <a:noFill/>
-        </p:spPr>
-        <p:txBody>
-          <a:bodyPr wrap="square">
-            <a:spAutoFit/>
-          </a:bodyPr>
-          <a:lstStyle/>
-          <a:p>
-            <a:pPr>
-              <a:spcAft>
-                <a:spcPts val="1400"/>
-              </a:spcAft>
-            </a:pPr>
-            <a:r>
-              <a:rPr sz="1300" b="1">
-                <a:solidFill>
-                  <a:srgbClr val="EB5757"/>
-                </a:solidFill>
-                <a:latin typeface="DM Sans"/>
-              </a:rPr>
-              <a:t>✗  </a:t>
-            </a:r>
-            <a:r>
-              <a:rPr sz="1300" b="0">
-                <a:solidFill>
-                  <a:srgbClr val="4F4F4F"/>
-                </a:solidFill>
-                <a:latin typeface="DM Sans"/>
-              </a:rPr>
-              <a:t> Kein Ticketing oder Gäste-Einlass — es führt die Crew, nicht die Besucherschlange.</a:t>
-            </a:r>
-          </a:p>
-          <a:p>
-            <a:pPr>
-              <a:spcAft>
-                <a:spcPts val="1400"/>
-              </a:spcAft>
-            </a:pPr>
-            <a:r>
-              <a:rPr sz="1300" b="1">
-                <a:solidFill>
-                  <a:srgbClr val="EB5757"/>
-                </a:solidFill>
-                <a:latin typeface="DM Sans"/>
-              </a:rPr>
-              <a:t>✗  </a:t>
-            </a:r>
-            <a:r>
-              <a:rPr sz="1300" b="0">
-                <a:solidFill>
-                  <a:srgbClr val="4F4F4F"/>
-                </a:solidFill>
-                <a:latin typeface="DM Sans"/>
-              </a:rPr>
-              <a:t> Ersetzt keinen Funk. Es sorgt dafür, dass Funk wieder für Wichtiges frei ist.</a:t>
-            </a:r>
-          </a:p>
-          <a:p>
-            <a:pPr>
-              <a:spcAft>
-                <a:spcPts val="1400"/>
-              </a:spcAft>
-            </a:pPr>
-            <a:r>
-              <a:rPr sz="1300" b="1">
-                <a:solidFill>
-                  <a:srgbClr val="EB5757"/>
-                </a:solidFill>
-                <a:latin typeface="DM Sans"/>
-              </a:rPr>
-              <a:t>✗  </a:t>
-            </a:r>
-            <a:r>
-              <a:rPr sz="1300" b="0">
-                <a:solidFill>
-                  <a:srgbClr val="4F4F4F"/>
-                </a:solidFill>
-                <a:latin typeface="DM Sans"/>
-              </a:rPr>
-              <a:t> Keine Magie: Eure Stammdaten müssen einmal sauber rein. (CSV reicht, Dry-Run inklusive.)</a:t>
-            </a:r>
-          </a:p>
-        </p:txBody>
-      </p:sp>
-      <p:sp>
-        <p:nvSpPr>
-          <p:cNvPr id="6" name="TextBox 5"/>
-          <p:cNvSpPr txBox="1"/>
-          <p:nvPr/>
-        </p:nvSpPr>
-        <p:spPr>
-          <a:xfrm>
-            <a:off x="6263640" y="2240280"/>
-            <a:ext cx="5212080" cy="3291840"/>
-          </a:xfrm>
-          <a:prstGeom prst="rect">
-            <a:avLst/>
-          </a:prstGeom>
-          <a:noFill/>
-        </p:spPr>
-        <p:txBody>
-          <a:bodyPr wrap="square">
-            <a:spAutoFit/>
-          </a:bodyPr>
-          <a:lstStyle/>
-          <a:p>
-            <a:pPr>
-              <a:spcAft>
-                <a:spcPts val="1400"/>
-              </a:spcAft>
-            </a:pPr>
-            <a:r>
-              <a:rPr sz="1300" b="1">
-                <a:solidFill>
-                  <a:srgbClr val="27AE60"/>
-                </a:solidFill>
-                <a:latin typeface="DM Sans"/>
-              </a:rPr>
-              <a:t>✓  </a:t>
-            </a:r>
-            <a:r>
-              <a:rPr sz="1300" b="0">
-                <a:solidFill>
-                  <a:srgbClr val="4F4F4F"/>
-                </a:solidFill>
-                <a:latin typeface="DM Sans"/>
-              </a:rPr>
-              <a:t> Dafür: ein System, das die komplette Eventnacht kennt — von Aufbau bis Übergabe.</a:t>
-            </a:r>
-          </a:p>
-          <a:p>
-            <a:pPr>
-              <a:spcAft>
-                <a:spcPts val="1400"/>
-              </a:spcAft>
-            </a:pPr>
-            <a:r>
-              <a:rPr sz="1300" b="1">
-                <a:solidFill>
-                  <a:srgbClr val="27AE60"/>
-                </a:solidFill>
-                <a:latin typeface="DM Sans"/>
-              </a:rPr>
-              <a:t>✓  </a:t>
-            </a:r>
-            <a:r>
-              <a:rPr sz="1300" b="0">
-                <a:solidFill>
-                  <a:srgbClr val="4F4F4F"/>
-                </a:solidFill>
-                <a:latin typeface="DM Sans"/>
-              </a:rPr>
-              <a:t> Dafür: ein Testlauf VOR der Saison, damit die Generalprobe die Probleme findet, nicht die Premiere.</a:t>
-            </a:r>
-          </a:p>
-          <a:p>
-            <a:pPr>
-              <a:spcAft>
-                <a:spcPts val="1400"/>
-              </a:spcAft>
-            </a:pPr>
-            <a:r>
-              <a:rPr sz="1300" b="1">
-                <a:solidFill>
-                  <a:srgbClr val="27AE60"/>
-                </a:solidFill>
-                <a:latin typeface="DM Sans"/>
-              </a:rPr>
-              <a:t>✓  </a:t>
-            </a:r>
-            <a:r>
-              <a:rPr sz="1300" b="0">
-                <a:solidFill>
-                  <a:srgbClr val="4F4F4F"/>
-                </a:solidFill>
-                <a:latin typeface="DM Sans"/>
-              </a:rPr>
-              <a:t> Dafür: ich bin in der Eventnacht erreichbar — nicht „der Support meldet sich werktags“.</a:t>
-            </a:r>
-          </a:p>
-        </p:txBody>
-      </p:sp>
-      <p:sp>
-        <p:nvSpPr>
-          <p:cNvPr id="7" name="Rectangle 6"/>
+                  <a:srgbClr val="CFD9E6"/>
+                </a:solidFill>
+                <a:latin typeface="DM Sans"/>
+              </a:rPr>
+              <a:t>Dünne Geräte, zentrale Wahrheit, robuste Betriebslogik. Läuft auf einem Laptop im Crew-Büro — kein Cloud-Zwang, keine Abhängigkeit von Festival-WLAN-Wundern.</a:t>
+            </a:r>
+          </a:p>
+        </p:txBody>
+      </p:sp>
+      <p:sp>
+        <p:nvSpPr>
+          <p:cNvPr id="5" name="Rounded Rectangle 4"/>
           <p:cNvSpPr/>
           <p:nvPr/>
         </p:nvSpPr>
         <p:spPr>
-          <a:xfrm rot="120000">
-            <a:off x="8138160" y="5394960"/>
-            <a:ext cx="3200400" cy="868680"/>
-          </a:xfrm>
-          <a:prstGeom prst="rect">
-            <a:avLst/>
+          <a:xfrm>
+            <a:off x="685800" y="2377440"/>
+            <a:ext cx="3502152" cy="2377440"/>
+          </a:xfrm>
+          <a:prstGeom prst="roundRect">
+            <a:avLst>
+              <a:gd name="adj" fmla="val 7000"/>
+            </a:avLst>
           </a:prstGeom>
           <a:solidFill>
-            <a:srgbClr val="FDF6E3"/>
+            <a:srgbClr val="143255"/>
           </a:solidFill>
-          <a:ln w="12700">
+          <a:ln w="9525">
             <a:solidFill>
-              <a:srgbClr val="E2B93B"/>
+              <a:srgbClr val="2A4A70"/>
             </a:solidFill>
           </a:ln>
           <a:effectLst/>
@@ -6317,27 +6044,358 @@
           </a:fontRef>
         </p:style>
         <p:txBody>
-          <a:bodyPr rtlCol="0" anchor="ctr" wrap="square" lIns="109728" rIns="109728" tIns="73152">
-            <a:noAutofit/>
-          </a:bodyPr>
+          <a:bodyPr rtlCol="0" anchor="t" wrap="square" lIns="146304" rIns="146304" tIns="109728" bIns="91440"/>
           <a:lstStyle/>
           <a:p>
             <a:pPr algn="ctr"/>
             <a:r>
-              <a:rPr sz="950" b="1">
-                <a:solidFill>
-                  <a:srgbClr val="6B5A1E"/>
+              <a:rPr sz="1250" b="1">
+                <a:solidFill>
+                  <a:srgbClr val="F8F6F2"/>
                 </a:solidFill>
                 <a:latin typeface="Nunito"/>
               </a:rPr>
-              <a:t>Ein Pitch, der Grenzen benennt, ist keiner mit Schwäche — sondern einer mit Plan.</a:t>
-            </a:r>
-          </a:p>
-        </p:txBody>
-      </p:sp>
-      <p:sp>
-        <p:nvSpPr>
-          <p:cNvPr id="8" name="TextBox 7"/>
+              <a:t>🧩 Null Abhängigkeiten</a:t>
+            </a:r>
+          </a:p>
+          <a:p>
+            <a:pPr>
+              <a:spcBef>
+                <a:spcPts val="400"/>
+              </a:spcBef>
+            </a:pPr>
+            <a:r>
+              <a:rPr sz="1050">
+                <a:solidFill>
+                  <a:srgbClr val="B9C6D6"/>
+                </a:solidFill>
+                <a:latin typeface="DM Sans"/>
+              </a:rPr>
+              <a:t>Ein Node.js-Server, keine fremden Pakete. PWA im Browser, native Shells für Windows/Android/iOS optional. Weniger Magie, mehr Kontrolle im Feld.</a:t>
+            </a:r>
+          </a:p>
+        </p:txBody>
+      </p:sp>
+      <p:sp>
+        <p:nvSpPr>
+          <p:cNvPr id="6" name="Rounded Rectangle 5"/>
+          <p:cNvSpPr/>
+          <p:nvPr/>
+        </p:nvSpPr>
+        <p:spPr>
+          <a:xfrm>
+            <a:off x="4416552" y="2377440"/>
+            <a:ext cx="3502152" cy="2377440"/>
+          </a:xfrm>
+          <a:prstGeom prst="roundRect">
+            <a:avLst>
+              <a:gd name="adj" fmla="val 7000"/>
+            </a:avLst>
+          </a:prstGeom>
+          <a:solidFill>
+            <a:srgbClr val="143255"/>
+          </a:solidFill>
+          <a:ln w="9525">
+            <a:solidFill>
+              <a:srgbClr val="2A4A70"/>
+            </a:solidFill>
+          </a:ln>
+          <a:effectLst/>
+        </p:spPr>
+        <p:style>
+          <a:lnRef idx="1">
+            <a:schemeClr val="accent1"/>
+          </a:lnRef>
+          <a:fillRef idx="3">
+            <a:schemeClr val="accent1"/>
+          </a:fillRef>
+          <a:effectRef idx="2">
+            <a:schemeClr val="accent1"/>
+          </a:effectRef>
+          <a:fontRef idx="minor">
+            <a:schemeClr val="lt1"/>
+          </a:fontRef>
+        </p:style>
+        <p:txBody>
+          <a:bodyPr rtlCol="0" anchor="t" wrap="square" lIns="146304" rIns="146304" tIns="109728" bIns="91440"/>
+          <a:lstStyle/>
+          <a:p>
+            <a:pPr algn="ctr"/>
+            <a:r>
+              <a:rPr sz="1250" b="1">
+                <a:solidFill>
+                  <a:srgbClr val="F8F6F2"/>
+                </a:solidFill>
+                <a:latin typeface="Nunito"/>
+              </a:rPr>
+              <a:t>⚡ Live ohne Refresh-Ritual</a:t>
+            </a:r>
+          </a:p>
+          <a:p>
+            <a:pPr>
+              <a:spcBef>
+                <a:spcPts val="400"/>
+              </a:spcBef>
+            </a:pPr>
+            <a:r>
+              <a:rPr sz="1050">
+                <a:solidFill>
+                  <a:srgbClr val="B9C6D6"/>
+                </a:solidFill>
+                <a:latin typeface="DM Sans"/>
+              </a:rPr>
+              <a:t>Server-Sent Events pushen jede Änderung an alle Sichten. Heartbeats erkennen Funklöcher, bevor sie ein Problem sind.</a:t>
+            </a:r>
+          </a:p>
+        </p:txBody>
+      </p:sp>
+      <p:sp>
+        <p:nvSpPr>
+          <p:cNvPr id="7" name="Rounded Rectangle 6"/>
+          <p:cNvSpPr/>
+          <p:nvPr/>
+        </p:nvSpPr>
+        <p:spPr>
+          <a:xfrm>
+            <a:off x="8147304" y="2377440"/>
+            <a:ext cx="3502152" cy="2377440"/>
+          </a:xfrm>
+          <a:prstGeom prst="roundRect">
+            <a:avLst>
+              <a:gd name="adj" fmla="val 7000"/>
+            </a:avLst>
+          </a:prstGeom>
+          <a:solidFill>
+            <a:srgbClr val="143255"/>
+          </a:solidFill>
+          <a:ln w="9525">
+            <a:solidFill>
+              <a:srgbClr val="2A4A70"/>
+            </a:solidFill>
+          </a:ln>
+          <a:effectLst/>
+        </p:spPr>
+        <p:style>
+          <a:lnRef idx="1">
+            <a:schemeClr val="accent1"/>
+          </a:lnRef>
+          <a:fillRef idx="3">
+            <a:schemeClr val="accent1"/>
+          </a:fillRef>
+          <a:effectRef idx="2">
+            <a:schemeClr val="accent1"/>
+          </a:effectRef>
+          <a:fontRef idx="minor">
+            <a:schemeClr val="lt1"/>
+          </a:fontRef>
+        </p:style>
+        <p:txBody>
+          <a:bodyPr rtlCol="0" anchor="t" wrap="square" lIns="146304" rIns="146304" tIns="109728" bIns="91440"/>
+          <a:lstStyle/>
+          <a:p>
+            <a:pPr algn="ctr"/>
+            <a:r>
+              <a:rPr sz="1250" b="1">
+                <a:solidFill>
+                  <a:srgbClr val="F8F6F2"/>
+                </a:solidFill>
+                <a:latin typeface="Nunito"/>
+              </a:rPr>
+              <a:t>🛡️ Unkaputtbar gedacht</a:t>
+            </a:r>
+          </a:p>
+          <a:p>
+            <a:pPr>
+              <a:spcBef>
+                <a:spcPts val="400"/>
+              </a:spcBef>
+            </a:pPr>
+            <a:r>
+              <a:rPr sz="1050">
+                <a:solidFill>
+                  <a:srgbClr val="B9C6D6"/>
+                </a:solidFill>
+                <a:latin typeface="DM Sans"/>
+              </a:rPr>
+              <a:t>Append-only-Journal, atomare Snapshots, rotierende Backups, Selbstreparatur beim Start. Stolpert ein Modul, läuft der Rest weiter (Circuit-Breaker).</a:t>
+            </a:r>
+          </a:p>
+        </p:txBody>
+      </p:sp>
+      <p:sp>
+        <p:nvSpPr>
+          <p:cNvPr id="8" name="Rounded Rectangle 7"/>
+          <p:cNvSpPr/>
+          <p:nvPr/>
+        </p:nvSpPr>
+        <p:spPr>
+          <a:xfrm>
+            <a:off x="685800" y="5120640"/>
+            <a:ext cx="2286000" cy="329184"/>
+          </a:xfrm>
+          <a:prstGeom prst="roundRect">
+            <a:avLst>
+              <a:gd name="adj" fmla="val 50000"/>
+            </a:avLst>
+          </a:prstGeom>
+          <a:solidFill>
+            <a:srgbClr val="143255"/>
+          </a:solidFill>
+          <a:ln w="9525">
+            <a:solidFill>
+              <a:srgbClr val="2A4A70"/>
+            </a:solidFill>
+          </a:ln>
+          <a:effectLst/>
+        </p:spPr>
+        <p:style>
+          <a:lnRef idx="1">
+            <a:schemeClr val="accent1"/>
+          </a:lnRef>
+          <a:fillRef idx="3">
+            <a:schemeClr val="accent1"/>
+          </a:fillRef>
+          <a:effectRef idx="2">
+            <a:schemeClr val="accent1"/>
+          </a:effectRef>
+          <a:fontRef idx="minor">
+            <a:schemeClr val="lt1"/>
+          </a:fontRef>
+        </p:style>
+        <p:txBody>
+          <a:bodyPr rtlCol="0" anchor="ctr" lIns="45720" rIns="45720" tIns="0" bIns="0"/>
+          <a:lstStyle/>
+          <a:p>
+            <a:pPr algn="ctr"/>
+            <a:r>
+              <a:rPr sz="1000" b="1">
+                <a:solidFill>
+                  <a:srgbClr val="CFD9E6"/>
+                </a:solidFill>
+                <a:latin typeface="DM Sans"/>
+              </a:rPr>
+              <a:t>125 API-End-to-End-Checks</a:t>
+            </a:r>
+          </a:p>
+        </p:txBody>
+      </p:sp>
+      <p:sp>
+        <p:nvSpPr>
+          <p:cNvPr id="9" name="Rounded Rectangle 8"/>
+          <p:cNvSpPr/>
+          <p:nvPr/>
+        </p:nvSpPr>
+        <p:spPr>
+          <a:xfrm>
+            <a:off x="3063240" y="5120640"/>
+            <a:ext cx="2011680" cy="329184"/>
+          </a:xfrm>
+          <a:prstGeom prst="roundRect">
+            <a:avLst>
+              <a:gd name="adj" fmla="val 50000"/>
+            </a:avLst>
+          </a:prstGeom>
+          <a:solidFill>
+            <a:srgbClr val="143255"/>
+          </a:solidFill>
+          <a:ln w="9525">
+            <a:solidFill>
+              <a:srgbClr val="2A4A70"/>
+            </a:solidFill>
+          </a:ln>
+          <a:effectLst/>
+        </p:spPr>
+        <p:style>
+          <a:lnRef idx="1">
+            <a:schemeClr val="accent1"/>
+          </a:lnRef>
+          <a:fillRef idx="3">
+            <a:schemeClr val="accent1"/>
+          </a:fillRef>
+          <a:effectRef idx="2">
+            <a:schemeClr val="accent1"/>
+          </a:effectRef>
+          <a:fontRef idx="minor">
+            <a:schemeClr val="lt1"/>
+          </a:fontRef>
+        </p:style>
+        <p:txBody>
+          <a:bodyPr rtlCol="0" anchor="ctr" lIns="45720" rIns="45720" tIns="0" bIns="0"/>
+          <a:lstStyle/>
+          <a:p>
+            <a:pPr algn="ctr"/>
+            <a:r>
+              <a:rPr sz="1000" b="1">
+                <a:solidFill>
+                  <a:srgbClr val="CFD9E6"/>
+                </a:solidFill>
+                <a:latin typeface="DM Sans"/>
+              </a:rPr>
+              <a:t>47 Browser-E2E-Checks</a:t>
+            </a:r>
+          </a:p>
+        </p:txBody>
+      </p:sp>
+      <p:sp>
+        <p:nvSpPr>
+          <p:cNvPr id="10" name="Rounded Rectangle 9"/>
+          <p:cNvSpPr/>
+          <p:nvPr/>
+        </p:nvSpPr>
+        <p:spPr>
+          <a:xfrm>
+            <a:off x="5166360" y="5120640"/>
+            <a:ext cx="4389120" cy="329184"/>
+          </a:xfrm>
+          <a:prstGeom prst="roundRect">
+            <a:avLst>
+              <a:gd name="adj" fmla="val 50000"/>
+            </a:avLst>
+          </a:prstGeom>
+          <a:solidFill>
+            <a:srgbClr val="143255"/>
+          </a:solidFill>
+          <a:ln w="9525">
+            <a:solidFill>
+              <a:srgbClr val="2A4A70"/>
+            </a:solidFill>
+          </a:ln>
+          <a:effectLst/>
+        </p:spPr>
+        <p:style>
+          <a:lnRef idx="1">
+            <a:schemeClr val="accent1"/>
+          </a:lnRef>
+          <a:fillRef idx="3">
+            <a:schemeClr val="accent1"/>
+          </a:fillRef>
+          <a:effectRef idx="2">
+            <a:schemeClr val="accent1"/>
+          </a:effectRef>
+          <a:fontRef idx="minor">
+            <a:schemeClr val="lt1"/>
+          </a:fontRef>
+        </p:style>
+        <p:txBody>
+          <a:bodyPr rtlCol="0" anchor="ctr" lIns="45720" rIns="45720" tIns="0" bIns="0"/>
+          <a:lstStyle/>
+          <a:p>
+            <a:pPr algn="ctr"/>
+            <a:r>
+              <a:rPr sz="1000" b="1">
+                <a:solidFill>
+                  <a:srgbClr val="CFD9E6"/>
+                </a:solidFill>
+                <a:latin typeface="DM Sans"/>
+              </a:rPr>
+              <a:t>CSV-Import mit Dry-Run — eure Excel darf einmal noch glänzen</a:t>
+            </a:r>
+          </a:p>
+        </p:txBody>
+      </p:sp>
+      <p:sp>
+        <p:nvSpPr>
+          <p:cNvPr id="11" name="TextBox 10"/>
           <p:cNvSpPr txBox="1"/>
           <p:nvPr/>
         </p:nvSpPr>
@@ -6360,18 +6418,18 @@
             <a:r>
               <a:rPr sz="900">
                 <a:solidFill>
-                  <a:srgbClr val="828282"/>
-                </a:solidFill>
-                <a:latin typeface="DM Sans"/>
-              </a:rPr>
-              <a:t>15 · Ehrlich gesagt</a:t>
-            </a:r>
-          </a:p>
-        </p:txBody>
-      </p:sp>
-      <p:sp>
-        <p:nvSpPr>
-          <p:cNvPr id="9" name="TextBox 8"/>
+                  <a:srgbClr val="7E93A9"/>
+                </a:solidFill>
+                <a:latin typeface="DM Sans"/>
+              </a:rPr>
+              <a:t>15 · Technik</a:t>
+            </a:r>
+          </a:p>
+        </p:txBody>
+      </p:sp>
+      <p:sp>
+        <p:nvSpPr>
+          <p:cNvPr id="12" name="TextBox 11"/>
           <p:cNvSpPr txBox="1"/>
           <p:nvPr/>
         </p:nvSpPr>
@@ -6395,7 +6453,7 @@
             <a:r>
               <a:rPr sz="900" i="1">
                 <a:solidFill>
-                  <a:srgbClr val="828282"/>
+                  <a:srgbClr val="7E93A9"/>
                 </a:solidFill>
                 <a:latin typeface="DM Sans"/>
               </a:rPr>
@@ -6459,7 +6517,7 @@
                 </a:solidFill>
                 <a:latin typeface="DM Sans"/>
               </a:rPr>
-              <a:t>DER WEG ZUR SAISON</a:t>
+              <a:t>ERWARTUNGSMANAGEMENT</a:t>
             </a:r>
           </a:p>
         </p:txBody>
@@ -6487,13 +6545,13 @@
           <a:lstStyle/>
           <a:p>
             <a:r>
-              <a:rPr sz="2600" b="1">
+              <a:rPr sz="3000" b="1">
                 <a:solidFill>
                   <a:srgbClr val="0D2847"/>
                 </a:solidFill>
                 <a:latin typeface="Nunito"/>
               </a:rPr>
-              <a:t>Von „klingt spannend“ zu „läuft live“ in sechs Schritten. 🗓️</a:t>
+              <a:t>Ehrlich gesagt — was es nicht ist. 🤝</a:t>
             </a:r>
           </a:p>
         </p:txBody>
@@ -6527,33 +6585,227 @@
                 </a:solidFill>
                 <a:latin typeface="DM Sans"/>
               </a:rPr>
-              <a:t>Bewusst mit Puffer: Die Generalprobe findet die Probleme, nicht die Premiere.</a:t>
-            </a:r>
-          </a:p>
-        </p:txBody>
-      </p:sp>
-      <p:sp>
-        <p:nvSpPr>
-          <p:cNvPr id="5" name="Rounded Rectangle 4"/>
+              <a:t>Damit wir über dasselbe reden. Lieber jetzt als am 31.10. um 22:15 Uhr.</a:t>
+            </a:r>
+          </a:p>
+        </p:txBody>
+      </p:sp>
+      <p:sp>
+        <p:nvSpPr>
+          <p:cNvPr id="5" name="TextBox 4"/>
+          <p:cNvSpPr txBox="1"/>
+          <p:nvPr/>
+        </p:nvSpPr>
+        <p:spPr>
+          <a:xfrm>
+            <a:off x="685800" y="2240280"/>
+            <a:ext cx="5212080" cy="3291840"/>
+          </a:xfrm>
+          <a:prstGeom prst="rect">
+            <a:avLst/>
+          </a:prstGeom>
+          <a:noFill/>
+        </p:spPr>
+        <p:txBody>
+          <a:bodyPr wrap="square">
+            <a:spAutoFit/>
+          </a:bodyPr>
+          <a:lstStyle/>
+          <a:p>
+            <a:pPr>
+              <a:spcAft>
+                <a:spcPts val="1400"/>
+              </a:spcAft>
+            </a:pPr>
+            <a:r>
+              <a:rPr sz="1300" b="1">
+                <a:solidFill>
+                  <a:srgbClr val="EB5757"/>
+                </a:solidFill>
+                <a:latin typeface="DM Sans"/>
+              </a:rPr>
+              <a:t>✗  </a:t>
+            </a:r>
+            <a:r>
+              <a:rPr sz="1300" b="0">
+                <a:solidFill>
+                  <a:srgbClr val="4F4F4F"/>
+                </a:solidFill>
+                <a:latin typeface="DM Sans"/>
+              </a:rPr>
+              <a:t> Kein Ticketing oder Gäste-Einlass — es führt die Crew, nicht die Besucherschlange.</a:t>
+            </a:r>
+          </a:p>
+          <a:p>
+            <a:pPr>
+              <a:spcAft>
+                <a:spcPts val="1400"/>
+              </a:spcAft>
+            </a:pPr>
+            <a:r>
+              <a:rPr sz="1300" b="1">
+                <a:solidFill>
+                  <a:srgbClr val="EB5757"/>
+                </a:solidFill>
+                <a:latin typeface="DM Sans"/>
+              </a:rPr>
+              <a:t>✗  </a:t>
+            </a:r>
+            <a:r>
+              <a:rPr sz="1300" b="0">
+                <a:solidFill>
+                  <a:srgbClr val="4F4F4F"/>
+                </a:solidFill>
+                <a:latin typeface="DM Sans"/>
+              </a:rPr>
+              <a:t> Ersetzt keinen Funk. Es sorgt dafür, dass Funk wieder für Wichtiges frei ist.</a:t>
+            </a:r>
+          </a:p>
+          <a:p>
+            <a:pPr>
+              <a:spcAft>
+                <a:spcPts val="1400"/>
+              </a:spcAft>
+            </a:pPr>
+            <a:r>
+              <a:rPr sz="1300" b="1">
+                <a:solidFill>
+                  <a:srgbClr val="EB5757"/>
+                </a:solidFill>
+                <a:latin typeface="DM Sans"/>
+              </a:rPr>
+              <a:t>✗  </a:t>
+            </a:r>
+            <a:r>
+              <a:rPr sz="1300" b="0">
+                <a:solidFill>
+                  <a:srgbClr val="4F4F4F"/>
+                </a:solidFill>
+                <a:latin typeface="DM Sans"/>
+              </a:rPr>
+              <a:t> Keine Magie: Eure Stammdaten müssen einmal sauber rein. (CSV reicht, Dry-Run inklusive.)</a:t>
+            </a:r>
+          </a:p>
+        </p:txBody>
+      </p:sp>
+      <p:sp>
+        <p:nvSpPr>
+          <p:cNvPr id="6" name="TextBox 5"/>
+          <p:cNvSpPr txBox="1"/>
+          <p:nvPr/>
+        </p:nvSpPr>
+        <p:spPr>
+          <a:xfrm>
+            <a:off x="6263640" y="2240280"/>
+            <a:ext cx="5212080" cy="3291840"/>
+          </a:xfrm>
+          <a:prstGeom prst="rect">
+            <a:avLst/>
+          </a:prstGeom>
+          <a:noFill/>
+        </p:spPr>
+        <p:txBody>
+          <a:bodyPr wrap="square">
+            <a:spAutoFit/>
+          </a:bodyPr>
+          <a:lstStyle/>
+          <a:p>
+            <a:pPr>
+              <a:spcAft>
+                <a:spcPts val="1400"/>
+              </a:spcAft>
+            </a:pPr>
+            <a:r>
+              <a:rPr sz="1300" b="1">
+                <a:solidFill>
+                  <a:srgbClr val="27AE60"/>
+                </a:solidFill>
+                <a:latin typeface="DM Sans"/>
+              </a:rPr>
+              <a:t>✓  </a:t>
+            </a:r>
+            <a:r>
+              <a:rPr sz="1300" b="0">
+                <a:solidFill>
+                  <a:srgbClr val="4F4F4F"/>
+                </a:solidFill>
+                <a:latin typeface="DM Sans"/>
+              </a:rPr>
+              <a:t> Dafür: ein System, das die komplette Eventnacht kennt — von Aufbau bis Übergabe.</a:t>
+            </a:r>
+          </a:p>
+          <a:p>
+            <a:pPr>
+              <a:spcAft>
+                <a:spcPts val="1400"/>
+              </a:spcAft>
+            </a:pPr>
+            <a:r>
+              <a:rPr sz="1300" b="1">
+                <a:solidFill>
+                  <a:srgbClr val="27AE60"/>
+                </a:solidFill>
+                <a:latin typeface="DM Sans"/>
+              </a:rPr>
+              <a:t>✓  </a:t>
+            </a:r>
+            <a:r>
+              <a:rPr sz="1300" b="0">
+                <a:solidFill>
+                  <a:srgbClr val="4F4F4F"/>
+                </a:solidFill>
+                <a:latin typeface="DM Sans"/>
+              </a:rPr>
+              <a:t> Dafür: ein Testlauf VOR der Saison, damit die Generalprobe die Probleme findet, nicht die Premiere.</a:t>
+            </a:r>
+          </a:p>
+          <a:p>
+            <a:pPr>
+              <a:spcAft>
+                <a:spcPts val="1400"/>
+              </a:spcAft>
+            </a:pPr>
+            <a:r>
+              <a:rPr sz="1300" b="1">
+                <a:solidFill>
+                  <a:srgbClr val="27AE60"/>
+                </a:solidFill>
+                <a:latin typeface="DM Sans"/>
+              </a:rPr>
+              <a:t>✓  </a:t>
+            </a:r>
+            <a:r>
+              <a:rPr sz="1300" b="0">
+                <a:solidFill>
+                  <a:srgbClr val="4F4F4F"/>
+                </a:solidFill>
+                <a:latin typeface="DM Sans"/>
+              </a:rPr>
+              <a:t> Dafür: ich bin in der Eventnacht erreichbar — nicht „der Support meldet sich werktags“.</a:t>
+            </a:r>
+          </a:p>
+        </p:txBody>
+      </p:sp>
+      <p:sp>
+        <p:nvSpPr>
+          <p:cNvPr id="7" name="Rectangle 6"/>
           <p:cNvSpPr/>
           <p:nvPr/>
         </p:nvSpPr>
         <p:spPr>
-          <a:xfrm>
-            <a:off x="685800" y="2468880"/>
-            <a:ext cx="1700784" cy="2377440"/>
-          </a:xfrm>
-          <a:prstGeom prst="roundRect">
-            <a:avLst>
-              <a:gd name="adj" fmla="val 6000"/>
-            </a:avLst>
+          <a:xfrm rot="120000">
+            <a:off x="8138160" y="5394960"/>
+            <a:ext cx="3200400" cy="868680"/>
+          </a:xfrm>
+          <a:prstGeom prst="rect">
+            <a:avLst/>
           </a:prstGeom>
           <a:solidFill>
-            <a:srgbClr val="FFFFFF"/>
+            <a:srgbClr val="FDF6E3"/>
           </a:solidFill>
-          <a:ln w="9525">
+          <a:ln w="12700">
             <a:solidFill>
-              <a:srgbClr val="E6E1D8"/>
+              <a:srgbClr val="E2B93B"/>
             </a:solidFill>
           </a:ln>
           <a:effectLst/>
@@ -6573,502 +6825,27 @@
           </a:fontRef>
         </p:style>
         <p:txBody>
-          <a:bodyPr rtlCol="0" anchor="t" wrap="square" lIns="109728" rIns="109728" tIns="109728"/>
+          <a:bodyPr rtlCol="0" anchor="ctr" wrap="square" lIns="109728" rIns="109728" tIns="73152">
+            <a:noAutofit/>
+          </a:bodyPr>
           <a:lstStyle/>
           <a:p>
             <a:pPr algn="ctr"/>
             <a:r>
-              <a:rPr sz="1000" b="1">
-                <a:solidFill>
-                  <a:srgbClr val="E08936"/>
-                </a:solidFill>
-                <a:latin typeface="DM Sans"/>
-              </a:rPr>
-              <a:t>JUNI</a:t>
-            </a:r>
-          </a:p>
-          <a:p>
-            <a:pPr>
-              <a:spcBef>
-                <a:spcPts val="300"/>
-              </a:spcBef>
-            </a:pPr>
-            <a:r>
-              <a:rPr sz="1300" b="1">
-                <a:solidFill>
-                  <a:srgbClr val="0D2847"/>
+              <a:rPr sz="950" b="1">
+                <a:solidFill>
+                  <a:srgbClr val="6B5A1E"/>
                 </a:solidFill>
                 <a:latin typeface="Nunito"/>
               </a:rPr>
-              <a:t>Demo-Termin</a:t>
-            </a:r>
-          </a:p>
-          <a:p>
-            <a:pPr>
-              <a:spcBef>
-                <a:spcPts val="400"/>
-              </a:spcBef>
-            </a:pPr>
-            <a:r>
-              <a:rPr sz="950">
-                <a:solidFill>
-                  <a:srgbClr val="4F4F4F"/>
-                </a:solidFill>
-                <a:latin typeface="DM Sans"/>
-              </a:rPr>
-              <a:t>30 min, Live-System, eure Fragen. Der Termin, den dieses Deck anpeilt.</a:t>
-            </a:r>
-          </a:p>
-        </p:txBody>
-      </p:sp>
-      <p:sp>
-        <p:nvSpPr>
-          <p:cNvPr id="6" name="Rounded Rectangle 5"/>
-          <p:cNvSpPr/>
-          <p:nvPr/>
-        </p:nvSpPr>
-        <p:spPr>
-          <a:xfrm>
-            <a:off x="2505456" y="2468880"/>
-            <a:ext cx="1700784" cy="2377440"/>
-          </a:xfrm>
-          <a:prstGeom prst="roundRect">
-            <a:avLst>
-              <a:gd name="adj" fmla="val 6000"/>
-            </a:avLst>
-          </a:prstGeom>
-          <a:solidFill>
-            <a:srgbClr val="FFFFFF"/>
-          </a:solidFill>
-          <a:ln w="9525">
-            <a:solidFill>
-              <a:srgbClr val="E6E1D8"/>
-            </a:solidFill>
-          </a:ln>
-          <a:effectLst/>
-        </p:spPr>
-        <p:style>
-          <a:lnRef idx="1">
-            <a:schemeClr val="accent1"/>
-          </a:lnRef>
-          <a:fillRef idx="3">
-            <a:schemeClr val="accent1"/>
-          </a:fillRef>
-          <a:effectRef idx="2">
-            <a:schemeClr val="accent1"/>
-          </a:effectRef>
-          <a:fontRef idx="minor">
-            <a:schemeClr val="lt1"/>
-          </a:fontRef>
-        </p:style>
-        <p:txBody>
-          <a:bodyPr rtlCol="0" anchor="t" wrap="square" lIns="109728" rIns="109728" tIns="109728"/>
-          <a:lstStyle/>
-          <a:p>
-            <a:pPr algn="ctr"/>
-            <a:r>
-              <a:rPr sz="1000" b="1">
-                <a:solidFill>
-                  <a:srgbClr val="E08936"/>
-                </a:solidFill>
-                <a:latin typeface="DM Sans"/>
-              </a:rPr>
-              <a:t>JULI</a:t>
-            </a:r>
-          </a:p>
-          <a:p>
-            <a:pPr>
-              <a:spcBef>
-                <a:spcPts val="300"/>
-              </a:spcBef>
-            </a:pPr>
-            <a:r>
-              <a:rPr sz="1300" b="1">
-                <a:solidFill>
-                  <a:srgbClr val="0D2847"/>
-                </a:solidFill>
-                <a:latin typeface="Nunito"/>
-              </a:rPr>
-              <a:t>Setup &amp; Daten</a:t>
-            </a:r>
-          </a:p>
-          <a:p>
-            <a:pPr>
-              <a:spcBef>
-                <a:spcPts val="400"/>
-              </a:spcBef>
-            </a:pPr>
-            <a:r>
-              <a:rPr sz="950">
-                <a:solidFill>
-                  <a:srgbClr val="4F4F4F"/>
-                </a:solidFill>
-                <a:latin typeface="DM Sans"/>
-              </a:rPr>
-              <a:t>Crew per CSV rein, Mazes &amp; Zonen, Rollen, Marken-Kontingente.</a:t>
-            </a:r>
-          </a:p>
-        </p:txBody>
-      </p:sp>
-      <p:sp>
-        <p:nvSpPr>
-          <p:cNvPr id="7" name="Rounded Rectangle 6"/>
-          <p:cNvSpPr/>
-          <p:nvPr/>
-        </p:nvSpPr>
-        <p:spPr>
-          <a:xfrm>
-            <a:off x="4325112" y="2468880"/>
-            <a:ext cx="1700784" cy="2377440"/>
-          </a:xfrm>
-          <a:prstGeom prst="roundRect">
-            <a:avLst>
-              <a:gd name="adj" fmla="val 6000"/>
-            </a:avLst>
-          </a:prstGeom>
-          <a:solidFill>
-            <a:srgbClr val="FFFFFF"/>
-          </a:solidFill>
-          <a:ln w="9525">
-            <a:solidFill>
-              <a:srgbClr val="E6E1D8"/>
-            </a:solidFill>
-          </a:ln>
-          <a:effectLst/>
-        </p:spPr>
-        <p:style>
-          <a:lnRef idx="1">
-            <a:schemeClr val="accent1"/>
-          </a:lnRef>
-          <a:fillRef idx="3">
-            <a:schemeClr val="accent1"/>
-          </a:fillRef>
-          <a:effectRef idx="2">
-            <a:schemeClr val="accent1"/>
-          </a:effectRef>
-          <a:fontRef idx="minor">
-            <a:schemeClr val="lt1"/>
-          </a:fontRef>
-        </p:style>
-        <p:txBody>
-          <a:bodyPr rtlCol="0" anchor="t" wrap="square" lIns="109728" rIns="109728" tIns="109728"/>
-          <a:lstStyle/>
-          <a:p>
-            <a:pPr algn="ctr"/>
-            <a:r>
-              <a:rPr sz="1000" b="1">
-                <a:solidFill>
-                  <a:srgbClr val="E08936"/>
-                </a:solidFill>
-                <a:latin typeface="DM Sans"/>
-              </a:rPr>
-              <a:t>AUGUST</a:t>
-            </a:r>
-          </a:p>
-          <a:p>
-            <a:pPr>
-              <a:spcBef>
-                <a:spcPts val="300"/>
-              </a:spcBef>
-            </a:pPr>
-            <a:r>
-              <a:rPr sz="1300" b="1">
-                <a:solidFill>
-                  <a:srgbClr val="0D2847"/>
-                </a:solidFill>
-                <a:latin typeface="Nunito"/>
-              </a:rPr>
-              <a:t>Schulung</a:t>
-            </a:r>
-          </a:p>
-          <a:p>
-            <a:pPr>
-              <a:spcBef>
-                <a:spcPts val="400"/>
-              </a:spcBef>
-            </a:pPr>
-            <a:r>
-              <a:rPr sz="950">
-                <a:solidFill>
-                  <a:srgbClr val="4F4F4F"/>
-                </a:solidFill>
-                <a:latin typeface="DM Sans"/>
-              </a:rPr>
-              <a:t>2 kurze Sessions: Leitstand &amp; Leads, Catering &amp; Actors. Mit Spickzetteln.</a:t>
-            </a:r>
-          </a:p>
-        </p:txBody>
-      </p:sp>
-      <p:sp>
-        <p:nvSpPr>
-          <p:cNvPr id="8" name="Rounded Rectangle 7"/>
-          <p:cNvSpPr/>
-          <p:nvPr/>
-        </p:nvSpPr>
-        <p:spPr>
-          <a:xfrm>
-            <a:off x="6144768" y="2468880"/>
-            <a:ext cx="1700784" cy="2377440"/>
-          </a:xfrm>
-          <a:prstGeom prst="roundRect">
-            <a:avLst>
-              <a:gd name="adj" fmla="val 6000"/>
-            </a:avLst>
-          </a:prstGeom>
-          <a:solidFill>
-            <a:srgbClr val="FFFFFF"/>
-          </a:solidFill>
-          <a:ln w="9525">
-            <a:solidFill>
-              <a:srgbClr val="E6E1D8"/>
-            </a:solidFill>
-          </a:ln>
-          <a:effectLst/>
-        </p:spPr>
-        <p:style>
-          <a:lnRef idx="1">
-            <a:schemeClr val="accent1"/>
-          </a:lnRef>
-          <a:fillRef idx="3">
-            <a:schemeClr val="accent1"/>
-          </a:fillRef>
-          <a:effectRef idx="2">
-            <a:schemeClr val="accent1"/>
-          </a:effectRef>
-          <a:fontRef idx="minor">
-            <a:schemeClr val="lt1"/>
-          </a:fontRef>
-        </p:style>
-        <p:txBody>
-          <a:bodyPr rtlCol="0" anchor="t" wrap="square" lIns="109728" rIns="109728" tIns="109728"/>
-          <a:lstStyle/>
-          <a:p>
-            <a:pPr algn="ctr"/>
-            <a:r>
-              <a:rPr sz="1000" b="1">
-                <a:solidFill>
-                  <a:srgbClr val="E08936"/>
-                </a:solidFill>
-                <a:latin typeface="DM Sans"/>
-              </a:rPr>
-              <a:t>SEPTEMBER</a:t>
-            </a:r>
-          </a:p>
-          <a:p>
-            <a:pPr>
-              <a:spcBef>
-                <a:spcPts val="300"/>
-              </a:spcBef>
-            </a:pPr>
-            <a:r>
-              <a:rPr sz="1300" b="1">
-                <a:solidFill>
-                  <a:srgbClr val="0D2847"/>
-                </a:solidFill>
-                <a:latin typeface="Nunito"/>
-              </a:rPr>
-              <a:t>Generalprobe</a:t>
-            </a:r>
-          </a:p>
-          <a:p>
-            <a:pPr>
-              <a:spcBef>
-                <a:spcPts val="400"/>
-              </a:spcBef>
-            </a:pPr>
-            <a:r>
-              <a:rPr sz="950">
-                <a:solidFill>
-                  <a:srgbClr val="4F4F4F"/>
-                </a:solidFill>
-                <a:latin typeface="DM Sans"/>
-              </a:rPr>
-              <a:t>Trockenlauf mit echter Crew, Funkprobe, Checklisten scharf.</a:t>
-            </a:r>
-          </a:p>
-        </p:txBody>
-      </p:sp>
-      <p:sp>
-        <p:nvSpPr>
-          <p:cNvPr id="9" name="Rounded Rectangle 8"/>
-          <p:cNvSpPr/>
-          <p:nvPr/>
-        </p:nvSpPr>
-        <p:spPr>
-          <a:xfrm>
-            <a:off x="7964424" y="2468880"/>
-            <a:ext cx="1700784" cy="2377440"/>
-          </a:xfrm>
-          <a:prstGeom prst="roundRect">
-            <a:avLst>
-              <a:gd name="adj" fmla="val 6000"/>
-            </a:avLst>
-          </a:prstGeom>
-          <a:solidFill>
-            <a:srgbClr val="FFFFFF"/>
-          </a:solidFill>
-          <a:ln w="9525">
-            <a:solidFill>
-              <a:srgbClr val="E6E1D8"/>
-            </a:solidFill>
-          </a:ln>
-          <a:effectLst/>
-        </p:spPr>
-        <p:style>
-          <a:lnRef idx="1">
-            <a:schemeClr val="accent1"/>
-          </a:lnRef>
-          <a:fillRef idx="3">
-            <a:schemeClr val="accent1"/>
-          </a:fillRef>
-          <a:effectRef idx="2">
-            <a:schemeClr val="accent1"/>
-          </a:effectRef>
-          <a:fontRef idx="minor">
-            <a:schemeClr val="lt1"/>
-          </a:fontRef>
-        </p:style>
-        <p:txBody>
-          <a:bodyPr rtlCol="0" anchor="t" wrap="square" lIns="109728" rIns="109728" tIns="109728"/>
-          <a:lstStyle/>
-          <a:p>
-            <a:pPr algn="ctr"/>
-            <a:r>
-              <a:rPr sz="1000" b="1">
-                <a:solidFill>
-                  <a:srgbClr val="E08936"/>
-                </a:solidFill>
-                <a:latin typeface="DM Sans"/>
-              </a:rPr>
-              <a:t>OKTOBER</a:t>
-            </a:r>
-          </a:p>
-          <a:p>
-            <a:pPr>
-              <a:spcBef>
-                <a:spcPts val="300"/>
-              </a:spcBef>
-            </a:pPr>
-            <a:r>
-              <a:rPr sz="1300" b="1">
-                <a:solidFill>
-                  <a:srgbClr val="0D2847"/>
-                </a:solidFill>
-                <a:latin typeface="Nunito"/>
-              </a:rPr>
-              <a:t>🎃 Live</a:t>
-            </a:r>
-          </a:p>
-          <a:p>
-            <a:pPr>
-              <a:spcBef>
-                <a:spcPts val="400"/>
-              </a:spcBef>
-            </a:pPr>
-            <a:r>
-              <a:rPr sz="950">
-                <a:solidFill>
-                  <a:srgbClr val="4F4F4F"/>
-                </a:solidFill>
-                <a:latin typeface="DM Sans"/>
-              </a:rPr>
-              <a:t>Eventnacht(en) mit Support vor Ort bzw. Rufbereitschaft.</a:t>
-            </a:r>
-          </a:p>
-        </p:txBody>
-      </p:sp>
-      <p:sp>
-        <p:nvSpPr>
-          <p:cNvPr id="10" name="Rounded Rectangle 9"/>
-          <p:cNvSpPr/>
-          <p:nvPr/>
-        </p:nvSpPr>
-        <p:spPr>
-          <a:xfrm>
-            <a:off x="9784080" y="2468880"/>
-            <a:ext cx="1700784" cy="2377440"/>
-          </a:xfrm>
-          <a:prstGeom prst="roundRect">
-            <a:avLst>
-              <a:gd name="adj" fmla="val 6000"/>
-            </a:avLst>
-          </a:prstGeom>
-          <a:solidFill>
-            <a:srgbClr val="FFFFFF"/>
-          </a:solidFill>
-          <a:ln w="9525">
-            <a:solidFill>
-              <a:srgbClr val="E6E1D8"/>
-            </a:solidFill>
-          </a:ln>
-          <a:effectLst/>
-        </p:spPr>
-        <p:style>
-          <a:lnRef idx="1">
-            <a:schemeClr val="accent1"/>
-          </a:lnRef>
-          <a:fillRef idx="3">
-            <a:schemeClr val="accent1"/>
-          </a:fillRef>
-          <a:effectRef idx="2">
-            <a:schemeClr val="accent1"/>
-          </a:effectRef>
-          <a:fontRef idx="minor">
-            <a:schemeClr val="lt1"/>
-          </a:fontRef>
-        </p:style>
-        <p:txBody>
-          <a:bodyPr rtlCol="0" anchor="t" wrap="square" lIns="109728" rIns="109728" tIns="109728"/>
-          <a:lstStyle/>
-          <a:p>
-            <a:pPr algn="ctr"/>
-            <a:r>
-              <a:rPr sz="1000" b="1">
-                <a:solidFill>
-                  <a:srgbClr val="E08936"/>
-                </a:solidFill>
-                <a:latin typeface="DM Sans"/>
-              </a:rPr>
-              <a:t>NOVEMBER</a:t>
-            </a:r>
-          </a:p>
-          <a:p>
-            <a:pPr>
-              <a:spcBef>
-                <a:spcPts val="300"/>
-              </a:spcBef>
-            </a:pPr>
-            <a:r>
-              <a:rPr sz="1300" b="1">
-                <a:solidFill>
-                  <a:srgbClr val="0D2847"/>
-                </a:solidFill>
-                <a:latin typeface="Nunito"/>
-              </a:rPr>
-              <a:t>Nachlese</a:t>
-            </a:r>
-          </a:p>
-          <a:p>
-            <a:pPr>
-              <a:spcBef>
-                <a:spcPts val="400"/>
-              </a:spcBef>
-            </a:pPr>
-            <a:r>
-              <a:rPr sz="950">
-                <a:solidFill>
-                  <a:srgbClr val="4F4F4F"/>
-                </a:solidFill>
-                <a:latin typeface="DM Sans"/>
-              </a:rPr>
-              <a:t>Berichte, Lessons Learned, Wunschliste für nächstes Jahr.</a:t>
-            </a:r>
-          </a:p>
-        </p:txBody>
-      </p:sp>
-      <p:sp>
-        <p:nvSpPr>
-          <p:cNvPr id="11" name="TextBox 10"/>
+              <a:t>Ein Pitch, der Grenzen benennt, ist keiner mit Schwäche — sondern einer mit Plan.</a:t>
+            </a:r>
+          </a:p>
+        </p:txBody>
+      </p:sp>
+      <p:sp>
+        <p:nvSpPr>
+          <p:cNvPr id="8" name="TextBox 7"/>
           <p:cNvSpPr txBox="1"/>
           <p:nvPr/>
         </p:nvSpPr>
@@ -7095,14 +6872,14 @@
                 </a:solidFill>
                 <a:latin typeface="DM Sans"/>
               </a:rPr>
-              <a:t>16 · Plan</a:t>
-            </a:r>
-          </a:p>
-        </p:txBody>
-      </p:sp>
-      <p:sp>
-        <p:nvSpPr>
-          <p:cNvPr id="12" name="TextBox 11"/>
+              <a:t>16 · Ehrlich gesagt</a:t>
+            </a:r>
+          </a:p>
+        </p:txBody>
+      </p:sp>
+      <p:sp>
+        <p:nvSpPr>
+          <p:cNvPr id="9" name="TextBox 8"/>
           <p:cNvSpPr txBox="1"/>
           <p:nvPr/>
         </p:nvSpPr>
@@ -7190,7 +6967,7 @@
                 </a:solidFill>
                 <a:latin typeface="DM Sans"/>
               </a:rPr>
-              <a:t>INVESTITION</a:t>
+              <a:t>DER WEG ZUR SAISON</a:t>
             </a:r>
           </a:p>
         </p:txBody>
@@ -7218,13 +6995,13 @@
           <a:lstStyle/>
           <a:p>
             <a:r>
-              <a:rPr sz="2700" b="1">
+              <a:rPr sz="2600" b="1">
                 <a:solidFill>
                   <a:srgbClr val="0D2847"/>
                 </a:solidFill>
                 <a:latin typeface="Nunito"/>
               </a:rPr>
-              <a:t>Die Entwicklung ist schon bezahlt — mit Herzblut. 🩸</a:t>
+              <a:t>Von „klingt spannend“ zu „läuft live“ in sechs Schritten. 🗓️</a:t>
             </a:r>
           </a:p>
         </p:txBody>
@@ -7258,7 +7035,7 @@
                 </a:solidFill>
                 <a:latin typeface="DM Sans"/>
               </a:rPr>
-              <a:t>Die Plattform existiert, ihr zahlt keine Produktentwicklung. Was bleibt, ist das Saisonpaket: Einrichtung, Schulung, Generalprobe, Eventnacht-Support und Nachlese — zum Freundschaftspreis.</a:t>
+              <a:t>Bewusst mit Puffer: Die Generalprobe findet die Probleme, nicht die Premiere.</a:t>
             </a:r>
           </a:p>
         </p:txBody>
@@ -7271,8 +7048,8 @@
         </p:nvSpPr>
         <p:spPr>
           <a:xfrm>
-            <a:off x="1005840" y="2560320"/>
-            <a:ext cx="4389120" cy="2468880"/>
+            <a:off x="685800" y="2468880"/>
+            <a:ext cx="1700784" cy="2377440"/>
           </a:xfrm>
           <a:prstGeom prst="roundRect">
             <a:avLst>
@@ -7304,6 +7081,737 @@
           </a:fontRef>
         </p:style>
         <p:txBody>
+          <a:bodyPr rtlCol="0" anchor="t" wrap="square" lIns="109728" rIns="109728" tIns="109728"/>
+          <a:lstStyle/>
+          <a:p>
+            <a:pPr algn="ctr"/>
+            <a:r>
+              <a:rPr sz="1000" b="1">
+                <a:solidFill>
+                  <a:srgbClr val="E08936"/>
+                </a:solidFill>
+                <a:latin typeface="DM Sans"/>
+              </a:rPr>
+              <a:t>JUNI</a:t>
+            </a:r>
+          </a:p>
+          <a:p>
+            <a:pPr>
+              <a:spcBef>
+                <a:spcPts val="300"/>
+              </a:spcBef>
+            </a:pPr>
+            <a:r>
+              <a:rPr sz="1300" b="1">
+                <a:solidFill>
+                  <a:srgbClr val="0D2847"/>
+                </a:solidFill>
+                <a:latin typeface="Nunito"/>
+              </a:rPr>
+              <a:t>Demo-Termin</a:t>
+            </a:r>
+          </a:p>
+          <a:p>
+            <a:pPr>
+              <a:spcBef>
+                <a:spcPts val="400"/>
+              </a:spcBef>
+            </a:pPr>
+            <a:r>
+              <a:rPr sz="950">
+                <a:solidFill>
+                  <a:srgbClr val="4F4F4F"/>
+                </a:solidFill>
+                <a:latin typeface="DM Sans"/>
+              </a:rPr>
+              <a:t>30 min, Live-System, eure Fragen. Der Termin, den dieses Deck anpeilt.</a:t>
+            </a:r>
+          </a:p>
+        </p:txBody>
+      </p:sp>
+      <p:sp>
+        <p:nvSpPr>
+          <p:cNvPr id="6" name="Rounded Rectangle 5"/>
+          <p:cNvSpPr/>
+          <p:nvPr/>
+        </p:nvSpPr>
+        <p:spPr>
+          <a:xfrm>
+            <a:off x="2505456" y="2468880"/>
+            <a:ext cx="1700784" cy="2377440"/>
+          </a:xfrm>
+          <a:prstGeom prst="roundRect">
+            <a:avLst>
+              <a:gd name="adj" fmla="val 6000"/>
+            </a:avLst>
+          </a:prstGeom>
+          <a:solidFill>
+            <a:srgbClr val="FFFFFF"/>
+          </a:solidFill>
+          <a:ln w="9525">
+            <a:solidFill>
+              <a:srgbClr val="E6E1D8"/>
+            </a:solidFill>
+          </a:ln>
+          <a:effectLst/>
+        </p:spPr>
+        <p:style>
+          <a:lnRef idx="1">
+            <a:schemeClr val="accent1"/>
+          </a:lnRef>
+          <a:fillRef idx="3">
+            <a:schemeClr val="accent1"/>
+          </a:fillRef>
+          <a:effectRef idx="2">
+            <a:schemeClr val="accent1"/>
+          </a:effectRef>
+          <a:fontRef idx="minor">
+            <a:schemeClr val="lt1"/>
+          </a:fontRef>
+        </p:style>
+        <p:txBody>
+          <a:bodyPr rtlCol="0" anchor="t" wrap="square" lIns="109728" rIns="109728" tIns="109728"/>
+          <a:lstStyle/>
+          <a:p>
+            <a:pPr algn="ctr"/>
+            <a:r>
+              <a:rPr sz="1000" b="1">
+                <a:solidFill>
+                  <a:srgbClr val="E08936"/>
+                </a:solidFill>
+                <a:latin typeface="DM Sans"/>
+              </a:rPr>
+              <a:t>JULI</a:t>
+            </a:r>
+          </a:p>
+          <a:p>
+            <a:pPr>
+              <a:spcBef>
+                <a:spcPts val="300"/>
+              </a:spcBef>
+            </a:pPr>
+            <a:r>
+              <a:rPr sz="1300" b="1">
+                <a:solidFill>
+                  <a:srgbClr val="0D2847"/>
+                </a:solidFill>
+                <a:latin typeface="Nunito"/>
+              </a:rPr>
+              <a:t>Setup &amp; Daten</a:t>
+            </a:r>
+          </a:p>
+          <a:p>
+            <a:pPr>
+              <a:spcBef>
+                <a:spcPts val="400"/>
+              </a:spcBef>
+            </a:pPr>
+            <a:r>
+              <a:rPr sz="950">
+                <a:solidFill>
+                  <a:srgbClr val="4F4F4F"/>
+                </a:solidFill>
+                <a:latin typeface="DM Sans"/>
+              </a:rPr>
+              <a:t>Crew per CSV rein, Mazes &amp; Zonen, Rollen, Marken, Kids-Day-Modul.</a:t>
+            </a:r>
+          </a:p>
+        </p:txBody>
+      </p:sp>
+      <p:sp>
+        <p:nvSpPr>
+          <p:cNvPr id="7" name="Rounded Rectangle 6"/>
+          <p:cNvSpPr/>
+          <p:nvPr/>
+        </p:nvSpPr>
+        <p:spPr>
+          <a:xfrm>
+            <a:off x="4325112" y="2468880"/>
+            <a:ext cx="1700784" cy="2377440"/>
+          </a:xfrm>
+          <a:prstGeom prst="roundRect">
+            <a:avLst>
+              <a:gd name="adj" fmla="val 6000"/>
+            </a:avLst>
+          </a:prstGeom>
+          <a:solidFill>
+            <a:srgbClr val="FFFFFF"/>
+          </a:solidFill>
+          <a:ln w="9525">
+            <a:solidFill>
+              <a:srgbClr val="E6E1D8"/>
+            </a:solidFill>
+          </a:ln>
+          <a:effectLst/>
+        </p:spPr>
+        <p:style>
+          <a:lnRef idx="1">
+            <a:schemeClr val="accent1"/>
+          </a:lnRef>
+          <a:fillRef idx="3">
+            <a:schemeClr val="accent1"/>
+          </a:fillRef>
+          <a:effectRef idx="2">
+            <a:schemeClr val="accent1"/>
+          </a:effectRef>
+          <a:fontRef idx="minor">
+            <a:schemeClr val="lt1"/>
+          </a:fontRef>
+        </p:style>
+        <p:txBody>
+          <a:bodyPr rtlCol="0" anchor="t" wrap="square" lIns="109728" rIns="109728" tIns="109728"/>
+          <a:lstStyle/>
+          <a:p>
+            <a:pPr algn="ctr"/>
+            <a:r>
+              <a:rPr sz="1000" b="1">
+                <a:solidFill>
+                  <a:srgbClr val="E08936"/>
+                </a:solidFill>
+                <a:latin typeface="DM Sans"/>
+              </a:rPr>
+              <a:t>AUGUST</a:t>
+            </a:r>
+          </a:p>
+          <a:p>
+            <a:pPr>
+              <a:spcBef>
+                <a:spcPts val="300"/>
+              </a:spcBef>
+            </a:pPr>
+            <a:r>
+              <a:rPr sz="1300" b="1">
+                <a:solidFill>
+                  <a:srgbClr val="0D2847"/>
+                </a:solidFill>
+                <a:latin typeface="Nunito"/>
+              </a:rPr>
+              <a:t>Schulung</a:t>
+            </a:r>
+          </a:p>
+          <a:p>
+            <a:pPr>
+              <a:spcBef>
+                <a:spcPts val="400"/>
+              </a:spcBef>
+            </a:pPr>
+            <a:r>
+              <a:rPr sz="950">
+                <a:solidFill>
+                  <a:srgbClr val="4F4F4F"/>
+                </a:solidFill>
+                <a:latin typeface="DM Sans"/>
+              </a:rPr>
+              <a:t>2 kurze Sessions: Leitstand &amp; Leads, Catering &amp; Actors. Mit Spickzetteln.</a:t>
+            </a:r>
+          </a:p>
+        </p:txBody>
+      </p:sp>
+      <p:sp>
+        <p:nvSpPr>
+          <p:cNvPr id="8" name="Rounded Rectangle 7"/>
+          <p:cNvSpPr/>
+          <p:nvPr/>
+        </p:nvSpPr>
+        <p:spPr>
+          <a:xfrm>
+            <a:off x="6144768" y="2468880"/>
+            <a:ext cx="1700784" cy="2377440"/>
+          </a:xfrm>
+          <a:prstGeom prst="roundRect">
+            <a:avLst>
+              <a:gd name="adj" fmla="val 6000"/>
+            </a:avLst>
+          </a:prstGeom>
+          <a:solidFill>
+            <a:srgbClr val="FFFFFF"/>
+          </a:solidFill>
+          <a:ln w="9525">
+            <a:solidFill>
+              <a:srgbClr val="E6E1D8"/>
+            </a:solidFill>
+          </a:ln>
+          <a:effectLst/>
+        </p:spPr>
+        <p:style>
+          <a:lnRef idx="1">
+            <a:schemeClr val="accent1"/>
+          </a:lnRef>
+          <a:fillRef idx="3">
+            <a:schemeClr val="accent1"/>
+          </a:fillRef>
+          <a:effectRef idx="2">
+            <a:schemeClr val="accent1"/>
+          </a:effectRef>
+          <a:fontRef idx="minor">
+            <a:schemeClr val="lt1"/>
+          </a:fontRef>
+        </p:style>
+        <p:txBody>
+          <a:bodyPr rtlCol="0" anchor="t" wrap="square" lIns="109728" rIns="109728" tIns="109728"/>
+          <a:lstStyle/>
+          <a:p>
+            <a:pPr algn="ctr"/>
+            <a:r>
+              <a:rPr sz="1000" b="1">
+                <a:solidFill>
+                  <a:srgbClr val="E08936"/>
+                </a:solidFill>
+                <a:latin typeface="DM Sans"/>
+              </a:rPr>
+              <a:t>SEPTEMBER</a:t>
+            </a:r>
+          </a:p>
+          <a:p>
+            <a:pPr>
+              <a:spcBef>
+                <a:spcPts val="300"/>
+              </a:spcBef>
+            </a:pPr>
+            <a:r>
+              <a:rPr sz="1300" b="1">
+                <a:solidFill>
+                  <a:srgbClr val="0D2847"/>
+                </a:solidFill>
+                <a:latin typeface="Nunito"/>
+              </a:rPr>
+              <a:t>Generalprobe</a:t>
+            </a:r>
+          </a:p>
+          <a:p>
+            <a:pPr>
+              <a:spcBef>
+                <a:spcPts val="400"/>
+              </a:spcBef>
+            </a:pPr>
+            <a:r>
+              <a:rPr sz="950">
+                <a:solidFill>
+                  <a:srgbClr val="4F4F4F"/>
+                </a:solidFill>
+                <a:latin typeface="DM Sans"/>
+              </a:rPr>
+              <a:t>Trockenlauf mit echter Crew, Funkprobe, Checklisten scharf.</a:t>
+            </a:r>
+          </a:p>
+        </p:txBody>
+      </p:sp>
+      <p:sp>
+        <p:nvSpPr>
+          <p:cNvPr id="9" name="Rounded Rectangle 8"/>
+          <p:cNvSpPr/>
+          <p:nvPr/>
+        </p:nvSpPr>
+        <p:spPr>
+          <a:xfrm>
+            <a:off x="7964424" y="2468880"/>
+            <a:ext cx="1700784" cy="2377440"/>
+          </a:xfrm>
+          <a:prstGeom prst="roundRect">
+            <a:avLst>
+              <a:gd name="adj" fmla="val 6000"/>
+            </a:avLst>
+          </a:prstGeom>
+          <a:solidFill>
+            <a:srgbClr val="FFFFFF"/>
+          </a:solidFill>
+          <a:ln w="9525">
+            <a:solidFill>
+              <a:srgbClr val="E6E1D8"/>
+            </a:solidFill>
+          </a:ln>
+          <a:effectLst/>
+        </p:spPr>
+        <p:style>
+          <a:lnRef idx="1">
+            <a:schemeClr val="accent1"/>
+          </a:lnRef>
+          <a:fillRef idx="3">
+            <a:schemeClr val="accent1"/>
+          </a:fillRef>
+          <a:effectRef idx="2">
+            <a:schemeClr val="accent1"/>
+          </a:effectRef>
+          <a:fontRef idx="minor">
+            <a:schemeClr val="lt1"/>
+          </a:fontRef>
+        </p:style>
+        <p:txBody>
+          <a:bodyPr rtlCol="0" anchor="t" wrap="square" lIns="109728" rIns="109728" tIns="109728"/>
+          <a:lstStyle/>
+          <a:p>
+            <a:pPr algn="ctr"/>
+            <a:r>
+              <a:rPr sz="1000" b="1">
+                <a:solidFill>
+                  <a:srgbClr val="E08936"/>
+                </a:solidFill>
+                <a:latin typeface="DM Sans"/>
+              </a:rPr>
+              <a:t>OKTOBER</a:t>
+            </a:r>
+          </a:p>
+          <a:p>
+            <a:pPr>
+              <a:spcBef>
+                <a:spcPts val="300"/>
+              </a:spcBef>
+            </a:pPr>
+            <a:r>
+              <a:rPr sz="1300" b="1">
+                <a:solidFill>
+                  <a:srgbClr val="0D2847"/>
+                </a:solidFill>
+                <a:latin typeface="Nunito"/>
+              </a:rPr>
+              <a:t>🎃 Live</a:t>
+            </a:r>
+          </a:p>
+          <a:p>
+            <a:pPr>
+              <a:spcBef>
+                <a:spcPts val="400"/>
+              </a:spcBef>
+            </a:pPr>
+            <a:r>
+              <a:rPr sz="950">
+                <a:solidFill>
+                  <a:srgbClr val="4F4F4F"/>
+                </a:solidFill>
+                <a:latin typeface="DM Sans"/>
+              </a:rPr>
+              <a:t>Eventnacht(en) mit Remote-Rufbereitschaft — Nachtschicht inklusive.</a:t>
+            </a:r>
+          </a:p>
+        </p:txBody>
+      </p:sp>
+      <p:sp>
+        <p:nvSpPr>
+          <p:cNvPr id="10" name="Rounded Rectangle 9"/>
+          <p:cNvSpPr/>
+          <p:nvPr/>
+        </p:nvSpPr>
+        <p:spPr>
+          <a:xfrm>
+            <a:off x="9784080" y="2468880"/>
+            <a:ext cx="1700784" cy="2377440"/>
+          </a:xfrm>
+          <a:prstGeom prst="roundRect">
+            <a:avLst>
+              <a:gd name="adj" fmla="val 6000"/>
+            </a:avLst>
+          </a:prstGeom>
+          <a:solidFill>
+            <a:srgbClr val="FFFFFF"/>
+          </a:solidFill>
+          <a:ln w="9525">
+            <a:solidFill>
+              <a:srgbClr val="E6E1D8"/>
+            </a:solidFill>
+          </a:ln>
+          <a:effectLst/>
+        </p:spPr>
+        <p:style>
+          <a:lnRef idx="1">
+            <a:schemeClr val="accent1"/>
+          </a:lnRef>
+          <a:fillRef idx="3">
+            <a:schemeClr val="accent1"/>
+          </a:fillRef>
+          <a:effectRef idx="2">
+            <a:schemeClr val="accent1"/>
+          </a:effectRef>
+          <a:fontRef idx="minor">
+            <a:schemeClr val="lt1"/>
+          </a:fontRef>
+        </p:style>
+        <p:txBody>
+          <a:bodyPr rtlCol="0" anchor="t" wrap="square" lIns="109728" rIns="109728" tIns="109728"/>
+          <a:lstStyle/>
+          <a:p>
+            <a:pPr algn="ctr"/>
+            <a:r>
+              <a:rPr sz="1000" b="1">
+                <a:solidFill>
+                  <a:srgbClr val="E08936"/>
+                </a:solidFill>
+                <a:latin typeface="DM Sans"/>
+              </a:rPr>
+              <a:t>NOVEMBER</a:t>
+            </a:r>
+          </a:p>
+          <a:p>
+            <a:pPr>
+              <a:spcBef>
+                <a:spcPts val="300"/>
+              </a:spcBef>
+            </a:pPr>
+            <a:r>
+              <a:rPr sz="1300" b="1">
+                <a:solidFill>
+                  <a:srgbClr val="0D2847"/>
+                </a:solidFill>
+                <a:latin typeface="Nunito"/>
+              </a:rPr>
+              <a:t>Nachlese</a:t>
+            </a:r>
+          </a:p>
+          <a:p>
+            <a:pPr>
+              <a:spcBef>
+                <a:spcPts val="400"/>
+              </a:spcBef>
+            </a:pPr>
+            <a:r>
+              <a:rPr sz="950">
+                <a:solidFill>
+                  <a:srgbClr val="4F4F4F"/>
+                </a:solidFill>
+                <a:latin typeface="DM Sans"/>
+              </a:rPr>
+              <a:t>Berichte, Lessons Learned, Wunschliste für nächstes Jahr.</a:t>
+            </a:r>
+          </a:p>
+        </p:txBody>
+      </p:sp>
+      <p:sp>
+        <p:nvSpPr>
+          <p:cNvPr id="11" name="TextBox 10"/>
+          <p:cNvSpPr txBox="1"/>
+          <p:nvPr/>
+        </p:nvSpPr>
+        <p:spPr>
+          <a:xfrm>
+            <a:off x="685800" y="6455664"/>
+            <a:ext cx="5486400" cy="274320"/>
+          </a:xfrm>
+          <a:prstGeom prst="rect">
+            <a:avLst/>
+          </a:prstGeom>
+          <a:noFill/>
+        </p:spPr>
+        <p:txBody>
+          <a:bodyPr wrap="square">
+            <a:spAutoFit/>
+          </a:bodyPr>
+          <a:lstStyle/>
+          <a:p>
+            <a:r>
+              <a:rPr sz="900">
+                <a:solidFill>
+                  <a:srgbClr val="828282"/>
+                </a:solidFill>
+                <a:latin typeface="DM Sans"/>
+              </a:rPr>
+              <a:t>17 · Plan</a:t>
+            </a:r>
+          </a:p>
+        </p:txBody>
+      </p:sp>
+      <p:sp>
+        <p:nvSpPr>
+          <p:cNvPr id="12" name="TextBox 11"/>
+          <p:cNvSpPr txBox="1"/>
+          <p:nvPr/>
+        </p:nvSpPr>
+        <p:spPr>
+          <a:xfrm>
+            <a:off x="6675120" y="6455664"/>
+            <a:ext cx="4800600" cy="274320"/>
+          </a:xfrm>
+          <a:prstGeom prst="rect">
+            <a:avLst/>
+          </a:prstGeom>
+          <a:noFill/>
+        </p:spPr>
+        <p:txBody>
+          <a:bodyPr wrap="square">
+            <a:spAutoFit/>
+          </a:bodyPr>
+          <a:lstStyle/>
+          <a:p>
+            <a:pPr algn="r"/>
+            <a:r>
+              <a:rPr sz="900" i="1">
+                <a:solidFill>
+                  <a:srgbClr val="828282"/>
+                </a:solidFill>
+                <a:latin typeface="DM Sans"/>
+              </a:rPr>
+              <a:t>Excel darf wieder schlafen.</a:t>
+            </a:r>
+          </a:p>
+        </p:txBody>
+      </p:sp>
+    </p:spTree>
+  </p:cSld>
+  <p:clrMapOvr>
+    <a:masterClrMapping/>
+  </p:clrMapOvr>
+</p:sld>
+</file>
+
+<file path=ppt/slides/slide18.xml><?xml version="1.0" encoding="utf-8"?>
+<p:sld xmlns:a="http://schemas.openxmlformats.org/drawingml/2006/main" xmlns:p="http://schemas.openxmlformats.org/presentationml/2006/main" xmlns:r="http://schemas.openxmlformats.org/officeDocument/2006/relationships">
+  <p:cSld>
+    <p:bg>
+      <p:bgPr>
+        <a:solidFill>
+          <a:srgbClr val="F8F6F2"/>
+        </a:solidFill>
+        <a:effectLst/>
+      </p:bgPr>
+    </p:bg>
+    <p:spTree>
+      <p:nvGrpSpPr>
+        <p:cNvPr id="1" name=""/>
+        <p:cNvGrpSpPr/>
+        <p:nvPr/>
+      </p:nvGrpSpPr>
+      <p:grpSpPr/>
+      <p:sp>
+        <p:nvSpPr>
+          <p:cNvPr id="2" name="TextBox 1"/>
+          <p:cNvSpPr txBox="1"/>
+          <p:nvPr/>
+        </p:nvSpPr>
+        <p:spPr>
+          <a:xfrm>
+            <a:off x="685800" y="384048"/>
+            <a:ext cx="10789920" cy="320040"/>
+          </a:xfrm>
+          <a:prstGeom prst="rect">
+            <a:avLst/>
+          </a:prstGeom>
+          <a:noFill/>
+        </p:spPr>
+        <p:txBody>
+          <a:bodyPr wrap="square">
+            <a:spAutoFit/>
+          </a:bodyPr>
+          <a:lstStyle/>
+          <a:p>
+            <a:r>
+              <a:rPr sz="1200" b="1">
+                <a:solidFill>
+                  <a:srgbClr val="F2994A"/>
+                </a:solidFill>
+                <a:latin typeface="DM Sans"/>
+              </a:rPr>
+              <a:t>INVESTITION</a:t>
+            </a:r>
+          </a:p>
+        </p:txBody>
+      </p:sp>
+      <p:sp>
+        <p:nvSpPr>
+          <p:cNvPr id="3" name="TextBox 2"/>
+          <p:cNvSpPr txBox="1"/>
+          <p:nvPr/>
+        </p:nvSpPr>
+        <p:spPr>
+          <a:xfrm>
+            <a:off x="685800" y="658368"/>
+            <a:ext cx="10789920" cy="914400"/>
+          </a:xfrm>
+          <a:prstGeom prst="rect">
+            <a:avLst/>
+          </a:prstGeom>
+          <a:noFill/>
+        </p:spPr>
+        <p:txBody>
+          <a:bodyPr wrap="square">
+            <a:spAutoFit/>
+          </a:bodyPr>
+          <a:lstStyle/>
+          <a:p>
+            <a:r>
+              <a:rPr sz="2700" b="1">
+                <a:solidFill>
+                  <a:srgbClr val="0D2847"/>
+                </a:solidFill>
+                <a:latin typeface="Nunito"/>
+              </a:rPr>
+              <a:t>Die Entwicklung ist schon bezahlt — mit Herzblut. 🩸</a:t>
+            </a:r>
+          </a:p>
+        </p:txBody>
+      </p:sp>
+      <p:sp>
+        <p:nvSpPr>
+          <p:cNvPr id="4" name="TextBox 3"/>
+          <p:cNvSpPr txBox="1"/>
+          <p:nvPr/>
+        </p:nvSpPr>
+        <p:spPr>
+          <a:xfrm>
+            <a:off x="713232" y="1298448"/>
+            <a:ext cx="10058400" cy="822960"/>
+          </a:xfrm>
+          <a:prstGeom prst="rect">
+            <a:avLst/>
+          </a:prstGeom>
+          <a:noFill/>
+        </p:spPr>
+        <p:txBody>
+          <a:bodyPr wrap="square">
+            <a:spAutoFit/>
+          </a:bodyPr>
+          <a:lstStyle/>
+          <a:p>
+            <a:r>
+              <a:rPr sz="1400">
+                <a:solidFill>
+                  <a:srgbClr val="4F4F4F"/>
+                </a:solidFill>
+                <a:latin typeface="DM Sans"/>
+              </a:rPr>
+              <a:t>Die Plattform existiert, ihr zahlt keine Produktentwicklung. Was bleibt, ist das Saisonpaket: Einrichtung, Kids-Day-Modul, Schulung, Generalprobe, Eventnacht-Rufbereitschaft und Nachlese — zum Freundschaftspreis.</a:t>
+            </a:r>
+          </a:p>
+        </p:txBody>
+      </p:sp>
+      <p:sp>
+        <p:nvSpPr>
+          <p:cNvPr id="5" name="Rounded Rectangle 4"/>
+          <p:cNvSpPr/>
+          <p:nvPr/>
+        </p:nvSpPr>
+        <p:spPr>
+          <a:xfrm>
+            <a:off x="1005840" y="2560320"/>
+            <a:ext cx="4389120" cy="2468880"/>
+          </a:xfrm>
+          <a:prstGeom prst="roundRect">
+            <a:avLst>
+              <a:gd name="adj" fmla="val 6000"/>
+            </a:avLst>
+          </a:prstGeom>
+          <a:solidFill>
+            <a:srgbClr val="FFFFFF"/>
+          </a:solidFill>
+          <a:ln w="9525">
+            <a:solidFill>
+              <a:srgbClr val="E6E1D8"/>
+            </a:solidFill>
+          </a:ln>
+          <a:effectLst/>
+        </p:spPr>
+        <p:style>
+          <a:lnRef idx="1">
+            <a:schemeClr val="accent1"/>
+          </a:lnRef>
+          <a:fillRef idx="3">
+            <a:schemeClr val="accent1"/>
+          </a:fillRef>
+          <a:effectRef idx="2">
+            <a:schemeClr val="accent1"/>
+          </a:effectRef>
+          <a:fontRef idx="minor">
+            <a:schemeClr val="lt1"/>
+          </a:fontRef>
+        </p:style>
+        <p:txBody>
           <a:bodyPr rtlCol="0" anchor="ctr" wrap="square"/>
           <a:lstStyle/>
           <a:p>
@@ -7331,7 +7839,7 @@
                 </a:solidFill>
                 <a:latin typeface="Nunito"/>
               </a:rPr>
-              <a:t>9.400 €</a:t>
+              <a:t>12.800 €</a:t>
             </a:r>
           </a:p>
           <a:p>
@@ -7455,7 +7963,7 @@
                 </a:solidFill>
                 <a:latin typeface="Nunito"/>
               </a:rPr>
-              <a:t>3.400 €</a:t>
+              <a:t>4.400 €</a:t>
             </a:r>
           </a:p>
           <a:p>
@@ -7471,8 +7979,8 @@
                 </a:solidFill>
                 <a:latin typeface="DM Sans"/>
               </a:rPr>
-              <a:t>komplett — inkl. Eventnacht vor Ort.
-Details &amp; Positionen im Beiblatt „Kostenaufstellung“.</a:t>
+              <a:t>komplett — inkl. Kids-Day-Modul und
+Eventnacht-Rufbereitschaft. Details: Kostenblatt.</a:t>
             </a:r>
           </a:p>
         </p:txBody>
@@ -7506,7 +8014,7 @@
                 </a:solidFill>
                 <a:latin typeface="DM Sans"/>
               </a:rPr>
-              <a:t>Zahlbar 50 % bei Start, 50 % nach der Eventnacht. Backfisch-Garantie: siehe Beiblatt. 🐟</a:t>
+              <a:t>Zahlbar 50 % bei Start, 50 % nach der Eventnacht. Backfisch-Garantie: siehe Kostenblatt. 🐟</a:t>
             </a:r>
           </a:p>
         </p:txBody>
@@ -7540,7 +8048,7 @@
                 </a:solidFill>
                 <a:latin typeface="DM Sans"/>
               </a:rPr>
-              <a:t>17 · Investition</a:t>
+              <a:t>18 · Investition</a:t>
             </a:r>
           </a:p>
         </p:txBody>
@@ -7588,7 +8096,7 @@
 </p:sld>
 </file>
 
-<file path=ppt/slides/slide18.xml><?xml version="1.0" encoding="utf-8"?>
+<file path=ppt/slides/slide19.xml><?xml version="1.0" encoding="utf-8"?>
 <p:sld xmlns:a="http://schemas.openxmlformats.org/drawingml/2006/main" xmlns:p="http://schemas.openxmlformats.org/presentationml/2006/main" xmlns:r="http://schemas.openxmlformats.org/officeDocument/2006/relationships">
   <p:cSld>
     <p:bg>
@@ -8040,7 +8548,7 @@
                 </a:solidFill>
                 <a:latin typeface="DM Sans"/>
               </a:rPr>
-              <a:t>18 · Demo planen</a:t>
+              <a:t>19 · Demo planen</a:t>
             </a:r>
           </a:p>
         </p:txBody>

</xml_diff>